<commit_message>
Avance fase 2 OfiMatch APT
</commit_message>
<xml_diff>
--- a/fase2/Proyecto APT2.pptx
+++ b/fase2/Proyecto APT2.pptx
@@ -6,17 +6,16 @@
   </p:sldMasterIdLst>
   <p:sldIdLst>
     <p:sldId id="256" r:id="rId2"/>
-    <p:sldId id="257" r:id="rId3"/>
-    <p:sldId id="259" r:id="rId4"/>
-    <p:sldId id="260" r:id="rId5"/>
-    <p:sldId id="261" r:id="rId6"/>
-    <p:sldId id="262" r:id="rId7"/>
-    <p:sldId id="263" r:id="rId8"/>
-    <p:sldId id="265" r:id="rId9"/>
-    <p:sldId id="266" r:id="rId10"/>
-    <p:sldId id="267" r:id="rId11"/>
-    <p:sldId id="268" r:id="rId12"/>
-    <p:sldId id="264" r:id="rId13"/>
+    <p:sldId id="265" r:id="rId3"/>
+    <p:sldId id="270" r:id="rId4"/>
+    <p:sldId id="271" r:id="rId5"/>
+    <p:sldId id="273" r:id="rId6"/>
+    <p:sldId id="274" r:id="rId7"/>
+    <p:sldId id="276" r:id="rId8"/>
+    <p:sldId id="275" r:id="rId9"/>
+    <p:sldId id="269" r:id="rId10"/>
+    <p:sldId id="277" r:id="rId11"/>
+    <p:sldId id="264" r:id="rId12"/>
   </p:sldIdLst>
   <p:sldSz cx="12192000" cy="6858000"/>
   <p:notesSz cx="6858000" cy="9144000"/>
@@ -354,7 +353,7 @@
           <a:p>
             <a:fld id="{9AB3A824-1A51-4B26-AD58-A6D8E14F6C04}" type="datetimeFigureOut">
               <a:rPr lang="en-US" dirty="0"/>
-              <a:t>10/7/2026</a:t>
+              <a:t>10/14/2026</a:t>
             </a:fld>
             <a:endParaRPr lang="en-US" dirty="0"/>
           </a:p>
@@ -702,7 +701,7 @@
           <a:p>
             <a:fld id="{D857E33E-8B18-4087-B112-809917729534}" type="datetimeFigureOut">
               <a:rPr lang="en-US" dirty="0"/>
-              <a:t>10/7/2026</a:t>
+              <a:t>10/14/2026</a:t>
             </a:fld>
             <a:endParaRPr lang="en-US" dirty="0"/>
           </a:p>
@@ -1018,7 +1017,7 @@
           <a:p>
             <a:fld id="{D3FFE419-2371-464F-8239-3959401C3561}" type="datetimeFigureOut">
               <a:rPr lang="en-US" dirty="0"/>
-              <a:t>10/7/2026</a:t>
+              <a:t>10/14/2026</a:t>
             </a:fld>
             <a:endParaRPr lang="en-US" dirty="0"/>
           </a:p>
@@ -1279,7 +1278,7 @@
           <a:p>
             <a:fld id="{97D162C4-EDD9-4389-A98B-B87ECEA2A816}" type="datetimeFigureOut">
               <a:rPr lang="en-US" dirty="0"/>
-              <a:t>10/7/2026</a:t>
+              <a:t>10/14/2026</a:t>
             </a:fld>
             <a:endParaRPr lang="en-US" dirty="0"/>
           </a:p>
@@ -1700,7 +1699,7 @@
           <a:p>
             <a:fld id="{3E5059C3-6A89-4494-99FF-5A4D6FFD50EB}" type="datetimeFigureOut">
               <a:rPr lang="en-US" dirty="0"/>
-              <a:t>10/7/2026</a:t>
+              <a:t>10/14/2026</a:t>
             </a:fld>
             <a:endParaRPr lang="en-US" dirty="0"/>
           </a:p>
@@ -2028,7 +2027,7 @@
           <a:p>
             <a:fld id="{CA954B2F-12DE-47F5-8894-472B206D2E1E}" type="datetimeFigureOut">
               <a:rPr lang="en-US" dirty="0"/>
-              <a:t>10/7/2026</a:t>
+              <a:t>10/14/2026</a:t>
             </a:fld>
             <a:endParaRPr lang="en-US" dirty="0"/>
           </a:p>
@@ -2586,7 +2585,7 @@
           <a:p>
             <a:fld id="{3F30E46F-7819-4ACF-B48B-48222C2ACC88}" type="datetimeFigureOut">
               <a:rPr lang="en-US" dirty="0"/>
-              <a:t>10/7/2026</a:t>
+              <a:t>10/14/2026</a:t>
             </a:fld>
             <a:endParaRPr lang="en-US" dirty="0"/>
           </a:p>
@@ -2795,7 +2794,7 @@
           <a:p>
             <a:fld id="{1FAF3416-4057-4DAA-829D-4CA07428D088}" type="datetimeFigureOut">
               <a:rPr lang="en-US" dirty="0"/>
-              <a:t>10/7/2026</a:t>
+              <a:t>10/14/2026</a:t>
             </a:fld>
             <a:endParaRPr lang="en-US" dirty="0"/>
           </a:p>
@@ -3022,7 +3021,7 @@
           <a:p>
             <a:fld id="{921D9284-D300-4297-87F7-E791DCC15DB1}" type="datetimeFigureOut">
               <a:rPr lang="en-US" dirty="0"/>
-              <a:t>10/7/2026</a:t>
+              <a:t>10/14/2026</a:t>
             </a:fld>
             <a:endParaRPr lang="en-US" dirty="0"/>
           </a:p>
@@ -3405,7 +3404,7 @@
           <a:p>
             <a:fld id="{37D525BB-DA17-4BA0-B3C8-3AC3ABC827E6}" type="datetimeFigureOut">
               <a:rPr lang="en-US" dirty="0"/>
-              <a:t>10/7/2026</a:t>
+              <a:t>10/14/2026</a:t>
             </a:fld>
             <a:endParaRPr lang="en-US" dirty="0"/>
           </a:p>
@@ -3822,7 +3821,7 @@
           <a:p>
             <a:fld id="{B16C4C9A-3960-41CF-A4E9-2A8FB932454B}" type="datetimeFigureOut">
               <a:rPr lang="en-US" dirty="0"/>
-              <a:t>10/7/2026</a:t>
+              <a:t>10/14/2026</a:t>
             </a:fld>
             <a:endParaRPr lang="en-US" dirty="0"/>
           </a:p>
@@ -4140,7 +4139,7 @@
           <a:p>
             <a:fld id="{3CBC1C18-307B-4F68-A007-B5B542270E8D}" type="datetimeFigureOut">
               <a:rPr lang="en-US" dirty="0"/>
-              <a:t>10/7/2026</a:t>
+              <a:t>10/14/2026</a:t>
             </a:fld>
             <a:endParaRPr lang="en-US" dirty="0"/>
           </a:p>
@@ -4806,7 +4805,7 @@
         <p:cNvPr id="1" name="">
           <a:extLst>
             <a:ext uri="{FF2B5EF4-FFF2-40B4-BE49-F238E27FC236}">
-              <a16:creationId xmlns:a16="http://schemas.microsoft.com/office/drawing/2014/main" id="{8E09E6A5-5BC7-DB2D-BDE3-A1B5586933D0}"/>
+              <a16:creationId xmlns:a16="http://schemas.microsoft.com/office/drawing/2014/main" id="{5DC6F5ED-E24F-17BA-4A80-FACFDF5FF21D}"/>
             </a:ext>
           </a:extLst>
         </p:cNvPr>
@@ -4826,7 +4825,7 @@
           <p:cNvPr id="2" name="Title 1">
             <a:extLst>
               <a:ext uri="{FF2B5EF4-FFF2-40B4-BE49-F238E27FC236}">
-                <a16:creationId xmlns:a16="http://schemas.microsoft.com/office/drawing/2014/main" id="{519592E4-2572-B0CD-8588-70DDFDFECC31}"/>
+                <a16:creationId xmlns:a16="http://schemas.microsoft.com/office/drawing/2014/main" id="{974A8852-439C-063D-4DD8-4967CDD4AE53}"/>
               </a:ext>
             </a:extLst>
           </p:cNvPr>
@@ -4839,97 +4838,82 @@
         </p:nvSpPr>
         <p:spPr>
           <a:xfrm>
-            <a:off x="691569" y="76536"/>
-            <a:ext cx="2527120" cy="1077229"/>
-          </a:xfrm>
-        </p:spPr>
-        <p:txBody>
-          <a:bodyPr/>
-          <a:lstStyle/>
-          <a:p>
+            <a:off x="1011608" y="0"/>
+            <a:ext cx="7958331" cy="1077229"/>
+          </a:xfrm>
+        </p:spPr>
+        <p:txBody>
+          <a:bodyPr/>
+          <a:lstStyle/>
+          <a:p>
+            <a:pPr algn="l"/>
             <a:r>
               <a:rPr lang="es-CL" dirty="0"/>
-              <a:t>Evidencias</a:t>
-            </a:r>
-          </a:p>
-        </p:txBody>
-      </p:sp>
-      <p:sp>
-        <p:nvSpPr>
-          <p:cNvPr id="9" name="TextBox 8">
+              <a:t>Pendientes</a:t>
+            </a:r>
+            <a:br>
+              <a:rPr lang="es-CL" dirty="0"/>
+            </a:br>
+            <a:endParaRPr lang="es-CL" dirty="0"/>
+          </a:p>
+        </p:txBody>
+      </p:sp>
+      <p:sp>
+        <p:nvSpPr>
+          <p:cNvPr id="3" name="Content Placeholder 2">
             <a:extLst>
               <a:ext uri="{FF2B5EF4-FFF2-40B4-BE49-F238E27FC236}">
-                <a16:creationId xmlns:a16="http://schemas.microsoft.com/office/drawing/2014/main" id="{D4F40066-E870-D3CC-CFCE-9BEFB0FAF8B1}"/>
+                <a16:creationId xmlns:a16="http://schemas.microsoft.com/office/drawing/2014/main" id="{2645FCF6-BAF2-BC4A-6291-C310B9D04E6C}"/>
               </a:ext>
             </a:extLst>
           </p:cNvPr>
-          <p:cNvSpPr txBox="1"/>
-          <p:nvPr/>
-        </p:nvSpPr>
-        <p:spPr>
-          <a:xfrm>
-            <a:off x="5598215" y="696565"/>
-            <a:ext cx="4918891" cy="369332"/>
-          </a:xfrm>
-          <a:prstGeom prst="rect">
-            <a:avLst/>
-          </a:prstGeom>
-          <a:noFill/>
-        </p:spPr>
-        <p:txBody>
-          <a:bodyPr wrap="square" rtlCol="0">
-            <a:spAutoFit/>
+          <p:cNvSpPr>
+            <a:spLocks noGrp="1"/>
+          </p:cNvSpPr>
+          <p:nvPr>
+            <p:ph idx="1"/>
+          </p:nvPr>
+        </p:nvSpPr>
+        <p:spPr>
+          <a:xfrm>
+            <a:off x="1011608" y="538614"/>
+            <a:ext cx="5855536" cy="2782421"/>
+          </a:xfrm>
+        </p:spPr>
+        <p:txBody>
+          <a:bodyPr>
+            <a:normAutofit/>
           </a:bodyPr>
           <a:lstStyle/>
           <a:p>
             <a:r>
               <a:rPr lang="es-CL" dirty="0"/>
-              <a:t>Vista administrador</a:t>
-            </a:r>
-          </a:p>
-        </p:txBody>
-      </p:sp>
-      <p:sp>
-        <p:nvSpPr>
-          <p:cNvPr id="14" name="TextBox 13">
+              <a:t>Sistema de agendamientos</a:t>
+            </a:r>
+          </a:p>
+          <a:p>
+            <a:r>
+              <a:rPr lang="es-CL" dirty="0"/>
+              <a:t>Revisión final con pruebas</a:t>
+            </a:r>
+          </a:p>
+          <a:p>
+            <a:r>
+              <a:rPr lang="es-CL" dirty="0"/>
+              <a:t>Mejoras para el escalado del proyecto</a:t>
+            </a:r>
+          </a:p>
+          <a:p>
+            <a:endParaRPr lang="es-CL" dirty="0"/>
+          </a:p>
+        </p:txBody>
+      </p:sp>
+      <p:pic>
+        <p:nvPicPr>
+          <p:cNvPr id="4" name="Picture 3" descr="Google calendar logo - free Icon PNG, SVG, ICO, ICNS | Icon-Icons">
             <a:extLst>
               <a:ext uri="{FF2B5EF4-FFF2-40B4-BE49-F238E27FC236}">
-                <a16:creationId xmlns:a16="http://schemas.microsoft.com/office/drawing/2014/main" id="{DBB13E3C-6433-5C44-EA1E-C14D1A48B728}"/>
-              </a:ext>
-            </a:extLst>
-          </p:cNvPr>
-          <p:cNvSpPr txBox="1"/>
-          <p:nvPr/>
-        </p:nvSpPr>
-        <p:spPr>
-          <a:xfrm>
-            <a:off x="5598215" y="4054172"/>
-            <a:ext cx="3364992" cy="369332"/>
-          </a:xfrm>
-          <a:prstGeom prst="rect">
-            <a:avLst/>
-          </a:prstGeom>
-          <a:noFill/>
-        </p:spPr>
-        <p:txBody>
-          <a:bodyPr wrap="square" rtlCol="0">
-            <a:spAutoFit/>
-          </a:bodyPr>
-          <a:lstStyle/>
-          <a:p>
-            <a:r>
-              <a:rPr lang="es-CL" dirty="0"/>
-              <a:t>Vista usuario trabajador</a:t>
-            </a:r>
-          </a:p>
-        </p:txBody>
-      </p:sp>
-      <p:pic>
-        <p:nvPicPr>
-          <p:cNvPr id="4" name="Picture 3">
-            <a:extLst>
-              <a:ext uri="{FF2B5EF4-FFF2-40B4-BE49-F238E27FC236}">
-                <a16:creationId xmlns:a16="http://schemas.microsoft.com/office/drawing/2014/main" id="{23559905-60C9-E27C-6910-5AD63A8DB335}"/>
+                <a16:creationId xmlns:a16="http://schemas.microsoft.com/office/drawing/2014/main" id="{CF6E41B7-53EA-49CA-7FA2-7E208BD7B0B5}"/>
               </a:ext>
             </a:extLst>
           </p:cNvPr>
@@ -4946,8 +4930,8 @@
         </p:blipFill>
         <p:spPr>
           <a:xfrm>
-            <a:off x="0" y="615150"/>
-            <a:ext cx="5598215" cy="3085074"/>
+            <a:off x="9221399" y="3855720"/>
+            <a:ext cx="2438400" cy="2438400"/>
           </a:xfrm>
           <a:prstGeom prst="rect">
             <a:avLst/>
@@ -4956,10 +4940,10 @@
       </p:pic>
       <p:pic>
         <p:nvPicPr>
-          <p:cNvPr id="6" name="Picture 5">
+          <p:cNvPr id="7" name="Picture 6">
             <a:extLst>
               <a:ext uri="{FF2B5EF4-FFF2-40B4-BE49-F238E27FC236}">
-                <a16:creationId xmlns:a16="http://schemas.microsoft.com/office/drawing/2014/main" id="{E8E0267B-01E5-2BE9-0FBD-98820B725BC0}"/>
+                <a16:creationId xmlns:a16="http://schemas.microsoft.com/office/drawing/2014/main" id="{AB01C553-9A4F-D476-43F0-0647950CC750}"/>
               </a:ext>
             </a:extLst>
           </p:cNvPr>
@@ -4976,8 +4960,8 @@
         </p:blipFill>
         <p:spPr>
           <a:xfrm>
-            <a:off x="0" y="3700223"/>
-            <a:ext cx="5598215" cy="3028597"/>
+            <a:off x="1011608" y="2718162"/>
+            <a:ext cx="5606180" cy="2943498"/>
           </a:xfrm>
           <a:prstGeom prst="rect">
             <a:avLst/>
@@ -4987,7 +4971,7 @@
     </p:spTree>
     <p:extLst>
       <p:ext uri="{BB962C8B-B14F-4D97-AF65-F5344CB8AC3E}">
-        <p14:creationId xmlns:p14="http://schemas.microsoft.com/office/powerpoint/2010/main" val="4280413964"/>
+        <p14:creationId xmlns:p14="http://schemas.microsoft.com/office/powerpoint/2010/main" val="508612557"/>
       </p:ext>
     </p:extLst>
   </p:cSld>
@@ -4998,205 +4982,6 @@
 </file>
 
 <file path=ppt/slides/slide11.xml><?xml version="1.0" encoding="utf-8"?>
-<p:sld xmlns:a="http://schemas.openxmlformats.org/drawingml/2006/main" xmlns:r="http://schemas.openxmlformats.org/officeDocument/2006/relationships" xmlns:p="http://schemas.openxmlformats.org/presentationml/2006/main">
-  <p:cSld>
-    <p:spTree>
-      <p:nvGrpSpPr>
-        <p:cNvPr id="1" name="">
-          <a:extLst>
-            <a:ext uri="{FF2B5EF4-FFF2-40B4-BE49-F238E27FC236}">
-              <a16:creationId xmlns:a16="http://schemas.microsoft.com/office/drawing/2014/main" id="{2F7CCF2C-F974-405C-D2C1-8FFF9EC0140C}"/>
-            </a:ext>
-          </a:extLst>
-        </p:cNvPr>
-        <p:cNvGrpSpPr/>
-        <p:nvPr/>
-      </p:nvGrpSpPr>
-      <p:grpSpPr>
-        <a:xfrm>
-          <a:off x="0" y="0"/>
-          <a:ext cx="0" cy="0"/>
-          <a:chOff x="0" y="0"/>
-          <a:chExt cx="0" cy="0"/>
-        </a:xfrm>
-      </p:grpSpPr>
-      <p:sp>
-        <p:nvSpPr>
-          <p:cNvPr id="2" name="Title 1">
-            <a:extLst>
-              <a:ext uri="{FF2B5EF4-FFF2-40B4-BE49-F238E27FC236}">
-                <a16:creationId xmlns:a16="http://schemas.microsoft.com/office/drawing/2014/main" id="{B1521AB8-51D4-245F-1C66-65AA5934E48C}"/>
-              </a:ext>
-            </a:extLst>
-          </p:cNvPr>
-          <p:cNvSpPr>
-            <a:spLocks noGrp="1"/>
-          </p:cNvSpPr>
-          <p:nvPr>
-            <p:ph type="title"/>
-          </p:nvPr>
-        </p:nvSpPr>
-        <p:spPr>
-          <a:xfrm>
-            <a:off x="691569" y="76536"/>
-            <a:ext cx="2527120" cy="1077229"/>
-          </a:xfrm>
-        </p:spPr>
-        <p:txBody>
-          <a:bodyPr/>
-          <a:lstStyle/>
-          <a:p>
-            <a:r>
-              <a:rPr lang="es-CL" dirty="0"/>
-              <a:t>Evidencias</a:t>
-            </a:r>
-          </a:p>
-        </p:txBody>
-      </p:sp>
-      <p:sp>
-        <p:nvSpPr>
-          <p:cNvPr id="9" name="TextBox 8">
-            <a:extLst>
-              <a:ext uri="{FF2B5EF4-FFF2-40B4-BE49-F238E27FC236}">
-                <a16:creationId xmlns:a16="http://schemas.microsoft.com/office/drawing/2014/main" id="{13269734-6F45-B762-71A1-78DB17F04C49}"/>
-              </a:ext>
-            </a:extLst>
-          </p:cNvPr>
-          <p:cNvSpPr txBox="1"/>
-          <p:nvPr/>
-        </p:nvSpPr>
-        <p:spPr>
-          <a:xfrm>
-            <a:off x="6581540" y="1153765"/>
-            <a:ext cx="4918891" cy="369332"/>
-          </a:xfrm>
-          <a:prstGeom prst="rect">
-            <a:avLst/>
-          </a:prstGeom>
-          <a:noFill/>
-        </p:spPr>
-        <p:txBody>
-          <a:bodyPr wrap="square" rtlCol="0">
-            <a:spAutoFit/>
-          </a:bodyPr>
-          <a:lstStyle/>
-          <a:p>
-            <a:r>
-              <a:rPr lang="es-CL" dirty="0"/>
-              <a:t>Vista portafolio trabajador </a:t>
-            </a:r>
-          </a:p>
-        </p:txBody>
-      </p:sp>
-      <p:sp>
-        <p:nvSpPr>
-          <p:cNvPr id="14" name="TextBox 13">
-            <a:extLst>
-              <a:ext uri="{FF2B5EF4-FFF2-40B4-BE49-F238E27FC236}">
-                <a16:creationId xmlns:a16="http://schemas.microsoft.com/office/drawing/2014/main" id="{256E5498-8D40-FB6D-BA05-89309BDA16D6}"/>
-              </a:ext>
-            </a:extLst>
-          </p:cNvPr>
-          <p:cNvSpPr txBox="1"/>
-          <p:nvPr/>
-        </p:nvSpPr>
-        <p:spPr>
-          <a:xfrm>
-            <a:off x="5974065" y="4789669"/>
-            <a:ext cx="3364992" cy="369332"/>
-          </a:xfrm>
-          <a:prstGeom prst="rect">
-            <a:avLst/>
-          </a:prstGeom>
-          <a:noFill/>
-        </p:spPr>
-        <p:txBody>
-          <a:bodyPr wrap="square" rtlCol="0">
-            <a:spAutoFit/>
-          </a:bodyPr>
-          <a:lstStyle/>
-          <a:p>
-            <a:r>
-              <a:rPr lang="es-CL" dirty="0"/>
-              <a:t>Contacto</a:t>
-            </a:r>
-          </a:p>
-        </p:txBody>
-      </p:sp>
-      <p:pic>
-        <p:nvPicPr>
-          <p:cNvPr id="4" name="Picture 3">
-            <a:extLst>
-              <a:ext uri="{FF2B5EF4-FFF2-40B4-BE49-F238E27FC236}">
-                <a16:creationId xmlns:a16="http://schemas.microsoft.com/office/drawing/2014/main" id="{A012EBA0-01E7-CE11-A766-409A52F38516}"/>
-              </a:ext>
-            </a:extLst>
-          </p:cNvPr>
-          <p:cNvPicPr>
-            <a:picLocks noChangeAspect="1"/>
-          </p:cNvPicPr>
-          <p:nvPr/>
-        </p:nvPicPr>
-        <p:blipFill>
-          <a:blip r:embed="rId2"/>
-          <a:stretch>
-            <a:fillRect/>
-          </a:stretch>
-        </p:blipFill>
-        <p:spPr>
-          <a:xfrm>
-            <a:off x="0" y="869570"/>
-            <a:ext cx="6513576" cy="3124034"/>
-          </a:xfrm>
-          <a:prstGeom prst="rect">
-            <a:avLst/>
-          </a:prstGeom>
-        </p:spPr>
-      </p:pic>
-      <p:pic>
-        <p:nvPicPr>
-          <p:cNvPr id="6" name="Picture 5">
-            <a:extLst>
-              <a:ext uri="{FF2B5EF4-FFF2-40B4-BE49-F238E27FC236}">
-                <a16:creationId xmlns:a16="http://schemas.microsoft.com/office/drawing/2014/main" id="{0BFE4928-1353-0B8C-B955-A520F4BA5B33}"/>
-              </a:ext>
-            </a:extLst>
-          </p:cNvPr>
-          <p:cNvPicPr>
-            <a:picLocks noChangeAspect="1"/>
-          </p:cNvPicPr>
-          <p:nvPr/>
-        </p:nvPicPr>
-        <p:blipFill>
-          <a:blip r:embed="rId3"/>
-          <a:stretch>
-            <a:fillRect/>
-          </a:stretch>
-        </p:blipFill>
-        <p:spPr>
-          <a:xfrm>
-            <a:off x="894258" y="4207466"/>
-            <a:ext cx="4725059" cy="1533739"/>
-          </a:xfrm>
-          <a:prstGeom prst="rect">
-            <a:avLst/>
-          </a:prstGeom>
-        </p:spPr>
-      </p:pic>
-    </p:spTree>
-    <p:extLst>
-      <p:ext uri="{BB962C8B-B14F-4D97-AF65-F5344CB8AC3E}">
-        <p14:creationId xmlns:p14="http://schemas.microsoft.com/office/powerpoint/2010/main" val="3908226142"/>
-      </p:ext>
-    </p:extLst>
-  </p:cSld>
-  <p:clrMapOvr>
-    <a:masterClrMapping/>
-  </p:clrMapOvr>
-</p:sld>
-</file>
-
-<file path=ppt/slides/slide12.xml><?xml version="1.0" encoding="utf-8"?>
 <p:sld xmlns:a="http://schemas.openxmlformats.org/drawingml/2006/main" xmlns:r="http://schemas.openxmlformats.org/officeDocument/2006/relationships" xmlns:p="http://schemas.openxmlformats.org/presentationml/2006/main">
   <p:cSld>
     <p:spTree>
@@ -5271,8 +5056,8 @@
         </p:nvSpPr>
         <p:spPr>
           <a:xfrm>
-            <a:off x="1011608" y="720613"/>
-            <a:ext cx="10363528" cy="4857227"/>
+            <a:off x="1011608" y="70747"/>
+            <a:ext cx="9967124" cy="4016621"/>
           </a:xfrm>
         </p:spPr>
         <p:txBody>
@@ -5286,25 +5071,7 @@
             </a:pPr>
             <a:r>
               <a:rPr lang="es-CL" dirty="0"/>
-              <a:t>Servimatch busca entregar una solución que permita a los trabajadores independientes aumentar su visibilidad y llegar a nuevos clientes sin depender de los métodos convencionales y anticuados a este punto.</a:t>
-            </a:r>
-          </a:p>
-          <a:p>
-            <a:pPr marL="0" indent="0">
-              <a:buNone/>
-            </a:pPr>
-            <a:r>
-              <a:rPr lang="es-CL" dirty="0"/>
-              <a:t>Un portal que les ofrece a los trabajadores de estos rubros perfiles profesionales, exposición de portafolio y gestión de reservas.</a:t>
-            </a:r>
-          </a:p>
-          <a:p>
-            <a:pPr marL="0" indent="0">
-              <a:buNone/>
-            </a:pPr>
-            <a:r>
-              <a:rPr lang="es-CL" dirty="0"/>
-              <a:t>Se planea que este proyecto dentro de no mucho cuente con un producto mínimo viable funcional, que tenga funcionalidades de incorporar nuevos oficios y funcionalidades a futuro.</a:t>
+              <a:t>El desarrollo permitió integrar distintas tecnologías en una aplicación funcional. Las funcionalidades de búsqueda y contacto cumplen con los objetivos principales de la visión original del proyecto. Con la implementación del sistema de agendamiento y algunos ajustes, el MVP estaría completo, quedando como etapas futuras su mejora y escalamiento.</a:t>
             </a:r>
           </a:p>
         </p:txBody>
@@ -5323,1991 +5090,6 @@
 </file>
 
 <file path=ppt/slides/slide2.xml><?xml version="1.0" encoding="utf-8"?>
-<p:sld xmlns:a="http://schemas.openxmlformats.org/drawingml/2006/main" xmlns:r="http://schemas.openxmlformats.org/officeDocument/2006/relationships" xmlns:p="http://schemas.openxmlformats.org/presentationml/2006/main">
-  <p:cSld>
-    <p:spTree>
-      <p:nvGrpSpPr>
-        <p:cNvPr id="1" name=""/>
-        <p:cNvGrpSpPr/>
-        <p:nvPr/>
-      </p:nvGrpSpPr>
-      <p:grpSpPr>
-        <a:xfrm>
-          <a:off x="0" y="0"/>
-          <a:ext cx="0" cy="0"/>
-          <a:chOff x="0" y="0"/>
-          <a:chExt cx="0" cy="0"/>
-        </a:xfrm>
-      </p:grpSpPr>
-      <p:sp>
-        <p:nvSpPr>
-          <p:cNvPr id="2" name="Title 1">
-            <a:extLst>
-              <a:ext uri="{FF2B5EF4-FFF2-40B4-BE49-F238E27FC236}">
-                <a16:creationId xmlns:a16="http://schemas.microsoft.com/office/drawing/2014/main" id="{2CC8BA77-289E-34D2-E387-CC4F0B34DD17}"/>
-              </a:ext>
-            </a:extLst>
-          </p:cNvPr>
-          <p:cNvSpPr>
-            <a:spLocks noGrp="1"/>
-          </p:cNvSpPr>
-          <p:nvPr>
-            <p:ph type="title"/>
-          </p:nvPr>
-        </p:nvSpPr>
-        <p:spPr>
-          <a:xfrm>
-            <a:off x="1011608" y="0"/>
-            <a:ext cx="7958331" cy="1077229"/>
-          </a:xfrm>
-        </p:spPr>
-        <p:txBody>
-          <a:bodyPr/>
-          <a:lstStyle/>
-          <a:p>
-            <a:pPr algn="l"/>
-            <a:r>
-              <a:rPr lang="es-CL" dirty="0"/>
-              <a:t>Problema</a:t>
-            </a:r>
-          </a:p>
-        </p:txBody>
-      </p:sp>
-      <p:sp>
-        <p:nvSpPr>
-          <p:cNvPr id="3" name="Content Placeholder 2">
-            <a:extLst>
-              <a:ext uri="{FF2B5EF4-FFF2-40B4-BE49-F238E27FC236}">
-                <a16:creationId xmlns:a16="http://schemas.microsoft.com/office/drawing/2014/main" id="{19601AA5-B41E-2A9A-891D-913E1AECACC6}"/>
-              </a:ext>
-            </a:extLst>
-          </p:cNvPr>
-          <p:cNvSpPr>
-            <a:spLocks noGrp="1"/>
-          </p:cNvSpPr>
-          <p:nvPr>
-            <p:ph idx="1"/>
-          </p:nvPr>
-        </p:nvSpPr>
-        <p:spPr>
-          <a:xfrm>
-            <a:off x="1011609" y="1077229"/>
-            <a:ext cx="5526351" cy="5780771"/>
-          </a:xfrm>
-        </p:spPr>
-        <p:txBody>
-          <a:bodyPr/>
-          <a:lstStyle/>
-          <a:p>
-            <a:pPr marL="0" indent="0">
-              <a:buNone/>
-            </a:pPr>
-            <a:r>
-              <a:rPr lang="es-CL" dirty="0"/>
-              <a:t>A día de hoy existen muchas personas que están en trabajos independientes los cuales consiguen clientes solo por la razón de que fueron recomendados por un amigo, familiar o conocido.</a:t>
-            </a:r>
-          </a:p>
-          <a:p>
-            <a:pPr marL="0" indent="0">
-              <a:buNone/>
-            </a:pPr>
-            <a:r>
-              <a:rPr lang="es-CL" dirty="0"/>
-              <a:t>Esto hace que sus campos sean limitados y deban depender de las redes sociales para poder publicitarse, un espacio sobresaturado y que dependen de la suerte para poder surgir, no es confiable, un trabajador trabajo formal o independiente no debería depender de la suerte.</a:t>
-            </a:r>
-          </a:p>
-        </p:txBody>
-      </p:sp>
-      <p:pic>
-        <p:nvPicPr>
-          <p:cNvPr id="5" name="Picture 4" descr="Descubre cuánto gana un tatuador y por qué es una profesión de futuro">
-            <a:extLst>
-              <a:ext uri="{FF2B5EF4-FFF2-40B4-BE49-F238E27FC236}">
-                <a16:creationId xmlns:a16="http://schemas.microsoft.com/office/drawing/2014/main" id="{83BDF833-BECF-E13B-BC13-F724EB5E8A3E}"/>
-              </a:ext>
-            </a:extLst>
-          </p:cNvPr>
-          <p:cNvPicPr>
-            <a:picLocks noChangeAspect="1"/>
-          </p:cNvPicPr>
-          <p:nvPr/>
-        </p:nvPicPr>
-        <p:blipFill>
-          <a:blip r:embed="rId2"/>
-          <a:stretch>
-            <a:fillRect/>
-          </a:stretch>
-        </p:blipFill>
-        <p:spPr>
-          <a:xfrm>
-            <a:off x="8129016" y="538614"/>
-            <a:ext cx="3779520" cy="2519680"/>
-          </a:xfrm>
-          <a:prstGeom prst="rect">
-            <a:avLst/>
-          </a:prstGeom>
-        </p:spPr>
-      </p:pic>
-      <p:pic>
-        <p:nvPicPr>
-          <p:cNvPr id="6" name="Picture 5" descr="Imágenes de Practica uñas - Descarga gratuita en Magnific (antes Freepik)">
-            <a:extLst>
-              <a:ext uri="{FF2B5EF4-FFF2-40B4-BE49-F238E27FC236}">
-                <a16:creationId xmlns:a16="http://schemas.microsoft.com/office/drawing/2014/main" id="{60043EF3-0132-7824-628A-171BFFB5825C}"/>
-              </a:ext>
-            </a:extLst>
-          </p:cNvPr>
-          <p:cNvPicPr>
-            <a:picLocks noChangeAspect="1"/>
-          </p:cNvPicPr>
-          <p:nvPr/>
-        </p:nvPicPr>
-        <p:blipFill>
-          <a:blip r:embed="rId3"/>
-          <a:stretch>
-            <a:fillRect/>
-          </a:stretch>
-        </p:blipFill>
-        <p:spPr>
-          <a:xfrm>
-            <a:off x="6537960" y="2078244"/>
-            <a:ext cx="3621406" cy="2412342"/>
-          </a:xfrm>
-          <a:prstGeom prst="rect">
-            <a:avLst/>
-          </a:prstGeom>
-        </p:spPr>
-      </p:pic>
-      <p:pic>
-        <p:nvPicPr>
-          <p:cNvPr id="7" name="Picture 6" descr="30 Consejos de Fotógrafos Profesionales que te Ayudarán a Avanzar">
-            <a:extLst>
-              <a:ext uri="{FF2B5EF4-FFF2-40B4-BE49-F238E27FC236}">
-                <a16:creationId xmlns:a16="http://schemas.microsoft.com/office/drawing/2014/main" id="{4994B4F5-F6C9-1987-7073-30C73F7C9197}"/>
-              </a:ext>
-            </a:extLst>
-          </p:cNvPr>
-          <p:cNvPicPr>
-            <a:picLocks noChangeAspect="1"/>
-          </p:cNvPicPr>
-          <p:nvPr/>
-        </p:nvPicPr>
-        <p:blipFill>
-          <a:blip r:embed="rId4"/>
-          <a:stretch>
-            <a:fillRect/>
-          </a:stretch>
-        </p:blipFill>
-        <p:spPr>
-          <a:xfrm>
-            <a:off x="8409904" y="4338320"/>
-            <a:ext cx="3782096" cy="2519680"/>
-          </a:xfrm>
-          <a:prstGeom prst="rect">
-            <a:avLst/>
-          </a:prstGeom>
-        </p:spPr>
-      </p:pic>
-    </p:spTree>
-    <p:extLst>
-      <p:ext uri="{BB962C8B-B14F-4D97-AF65-F5344CB8AC3E}">
-        <p14:creationId xmlns:p14="http://schemas.microsoft.com/office/powerpoint/2010/main" val="655712466"/>
-      </p:ext>
-    </p:extLst>
-  </p:cSld>
-  <p:clrMapOvr>
-    <a:masterClrMapping/>
-  </p:clrMapOvr>
-</p:sld>
-</file>
-
-<file path=ppt/slides/slide3.xml><?xml version="1.0" encoding="utf-8"?>
-<p:sld xmlns:a="http://schemas.openxmlformats.org/drawingml/2006/main" xmlns:r="http://schemas.openxmlformats.org/officeDocument/2006/relationships" xmlns:p="http://schemas.openxmlformats.org/presentationml/2006/main">
-  <p:cSld>
-    <p:spTree>
-      <p:nvGrpSpPr>
-        <p:cNvPr id="1" name="">
-          <a:extLst>
-            <a:ext uri="{FF2B5EF4-FFF2-40B4-BE49-F238E27FC236}">
-              <a16:creationId xmlns:a16="http://schemas.microsoft.com/office/drawing/2014/main" id="{076AD087-D320-455F-F728-813B646F5FF7}"/>
-            </a:ext>
-          </a:extLst>
-        </p:cNvPr>
-        <p:cNvGrpSpPr/>
-        <p:nvPr/>
-      </p:nvGrpSpPr>
-      <p:grpSpPr>
-        <a:xfrm>
-          <a:off x="0" y="0"/>
-          <a:ext cx="0" cy="0"/>
-          <a:chOff x="0" y="0"/>
-          <a:chExt cx="0" cy="0"/>
-        </a:xfrm>
-      </p:grpSpPr>
-      <p:sp>
-        <p:nvSpPr>
-          <p:cNvPr id="2" name="Title 1">
-            <a:extLst>
-              <a:ext uri="{FF2B5EF4-FFF2-40B4-BE49-F238E27FC236}">
-                <a16:creationId xmlns:a16="http://schemas.microsoft.com/office/drawing/2014/main" id="{3B765565-3053-74C3-07FA-F1AD0CE50404}"/>
-              </a:ext>
-            </a:extLst>
-          </p:cNvPr>
-          <p:cNvSpPr>
-            <a:spLocks noGrp="1"/>
-          </p:cNvSpPr>
-          <p:nvPr>
-            <p:ph type="title"/>
-          </p:nvPr>
-        </p:nvSpPr>
-        <p:spPr>
-          <a:xfrm>
-            <a:off x="1011608" y="0"/>
-            <a:ext cx="7958331" cy="1077229"/>
-          </a:xfrm>
-        </p:spPr>
-        <p:txBody>
-          <a:bodyPr/>
-          <a:lstStyle/>
-          <a:p>
-            <a:pPr algn="l"/>
-            <a:r>
-              <a:rPr lang="es-CL" dirty="0"/>
-              <a:t>Solución</a:t>
-            </a:r>
-          </a:p>
-        </p:txBody>
-      </p:sp>
-      <p:sp>
-        <p:nvSpPr>
-          <p:cNvPr id="3" name="Content Placeholder 2">
-            <a:extLst>
-              <a:ext uri="{FF2B5EF4-FFF2-40B4-BE49-F238E27FC236}">
-                <a16:creationId xmlns:a16="http://schemas.microsoft.com/office/drawing/2014/main" id="{CB3E5F82-C908-02C3-807C-BAC8D0B03EC1}"/>
-              </a:ext>
-            </a:extLst>
-          </p:cNvPr>
-          <p:cNvSpPr>
-            <a:spLocks noGrp="1"/>
-          </p:cNvSpPr>
-          <p:nvPr>
-            <p:ph idx="1"/>
-          </p:nvPr>
-        </p:nvSpPr>
-        <p:spPr>
-          <a:xfrm>
-            <a:off x="1011609" y="1077229"/>
-            <a:ext cx="5864679" cy="5780771"/>
-          </a:xfrm>
-        </p:spPr>
-        <p:txBody>
-          <a:bodyPr>
-            <a:normAutofit/>
-          </a:bodyPr>
-          <a:lstStyle/>
-          <a:p>
-            <a:pPr marL="0" indent="0">
-              <a:buNone/>
-            </a:pPr>
-            <a:r>
-              <a:rPr lang="es-CL" dirty="0"/>
-              <a:t>Servimatch busca solucionar este problema como una plataforma tipo portal que ayude a la visibilización de sus servicios para ser encontrados por nuevos clientes, para que no dependan de la comunicación boca a boca o redes sociales.</a:t>
-            </a:r>
-          </a:p>
-          <a:p>
-            <a:pPr marL="0" indent="0">
-              <a:buNone/>
-            </a:pPr>
-            <a:r>
-              <a:rPr lang="es-CL" dirty="0"/>
-              <a:t>Cada trabajador contando con un perfil que pueda mostrar su portafolio profesional, estos sean tatuajes, manicure, cortes de cabello, fotógrafo, etc.</a:t>
-            </a:r>
-          </a:p>
-          <a:p>
-            <a:pPr marL="0" indent="0">
-              <a:buNone/>
-            </a:pPr>
-            <a:r>
-              <a:rPr lang="es-CL" dirty="0"/>
-              <a:t>Además de que los clientes podrán buscar y conocer distintos trabajadores, sus extensos portafolios y comunicarse con ellos para agendar el servicio que necesiten desde el portal</a:t>
-            </a:r>
-          </a:p>
-        </p:txBody>
-      </p:sp>
-      <p:pic>
-        <p:nvPicPr>
-          <p:cNvPr id="4" name="Picture 3" descr="25 de agosto | Día Internacional del Peluquero ✂ Siempre quise ser peluquera…  y ser peluquera en mi peluquería me hace inmensamente feliz. 💛 Detrás de  cada corte, cada color y cada">
-            <a:extLst>
-              <a:ext uri="{FF2B5EF4-FFF2-40B4-BE49-F238E27FC236}">
-                <a16:creationId xmlns:a16="http://schemas.microsoft.com/office/drawing/2014/main" id="{7D7341EF-D290-9975-8B43-7B350AB0C1E0}"/>
-              </a:ext>
-            </a:extLst>
-          </p:cNvPr>
-          <p:cNvPicPr>
-            <a:picLocks noChangeAspect="1"/>
-          </p:cNvPicPr>
-          <p:nvPr/>
-        </p:nvPicPr>
-        <p:blipFill>
-          <a:blip r:embed="rId2"/>
-          <a:stretch>
-            <a:fillRect/>
-          </a:stretch>
-        </p:blipFill>
-        <p:spPr>
-          <a:xfrm>
-            <a:off x="9043417" y="-1"/>
-            <a:ext cx="3148584" cy="3953485"/>
-          </a:xfrm>
-          <a:prstGeom prst="rect">
-            <a:avLst/>
-          </a:prstGeom>
-        </p:spPr>
-      </p:pic>
-      <p:pic>
-        <p:nvPicPr>
-          <p:cNvPr id="8" name="Picture 7" descr="Barberos in Vitacura - Booksy">
-            <a:extLst>
-              <a:ext uri="{FF2B5EF4-FFF2-40B4-BE49-F238E27FC236}">
-                <a16:creationId xmlns:a16="http://schemas.microsoft.com/office/drawing/2014/main" id="{C1322392-800D-15EC-758E-1BAA80468CE4}"/>
-              </a:ext>
-            </a:extLst>
-          </p:cNvPr>
-          <p:cNvPicPr>
-            <a:picLocks noChangeAspect="1"/>
-          </p:cNvPicPr>
-          <p:nvPr/>
-        </p:nvPicPr>
-        <p:blipFill>
-          <a:blip r:embed="rId3"/>
-          <a:stretch>
-            <a:fillRect/>
-          </a:stretch>
-        </p:blipFill>
-        <p:spPr>
-          <a:xfrm>
-            <a:off x="7896212" y="3953484"/>
-            <a:ext cx="4295788" cy="2916936"/>
-          </a:xfrm>
-          <a:prstGeom prst="rect">
-            <a:avLst/>
-          </a:prstGeom>
-        </p:spPr>
-      </p:pic>
-    </p:spTree>
-    <p:extLst>
-      <p:ext uri="{BB962C8B-B14F-4D97-AF65-F5344CB8AC3E}">
-        <p14:creationId xmlns:p14="http://schemas.microsoft.com/office/powerpoint/2010/main" val="1505392925"/>
-      </p:ext>
-    </p:extLst>
-  </p:cSld>
-  <p:clrMapOvr>
-    <a:masterClrMapping/>
-  </p:clrMapOvr>
-</p:sld>
-</file>
-
-<file path=ppt/slides/slide4.xml><?xml version="1.0" encoding="utf-8"?>
-<p:sld xmlns:a="http://schemas.openxmlformats.org/drawingml/2006/main" xmlns:r="http://schemas.openxmlformats.org/officeDocument/2006/relationships" xmlns:p="http://schemas.openxmlformats.org/presentationml/2006/main">
-  <p:cSld>
-    <p:spTree>
-      <p:nvGrpSpPr>
-        <p:cNvPr id="1" name="">
-          <a:extLst>
-            <a:ext uri="{FF2B5EF4-FFF2-40B4-BE49-F238E27FC236}">
-              <a16:creationId xmlns:a16="http://schemas.microsoft.com/office/drawing/2014/main" id="{3B1522BF-BE18-46DC-DA31-87065FA92F2D}"/>
-            </a:ext>
-          </a:extLst>
-        </p:cNvPr>
-        <p:cNvGrpSpPr/>
-        <p:nvPr/>
-      </p:nvGrpSpPr>
-      <p:grpSpPr>
-        <a:xfrm>
-          <a:off x="0" y="0"/>
-          <a:ext cx="0" cy="0"/>
-          <a:chOff x="0" y="0"/>
-          <a:chExt cx="0" cy="0"/>
-        </a:xfrm>
-      </p:grpSpPr>
-      <p:sp>
-        <p:nvSpPr>
-          <p:cNvPr id="2" name="Title 1">
-            <a:extLst>
-              <a:ext uri="{FF2B5EF4-FFF2-40B4-BE49-F238E27FC236}">
-                <a16:creationId xmlns:a16="http://schemas.microsoft.com/office/drawing/2014/main" id="{757A213C-0827-E5E4-B7CE-391A0C2E0A7E}"/>
-              </a:ext>
-            </a:extLst>
-          </p:cNvPr>
-          <p:cNvSpPr>
-            <a:spLocks noGrp="1"/>
-          </p:cNvSpPr>
-          <p:nvPr>
-            <p:ph type="title"/>
-          </p:nvPr>
-        </p:nvSpPr>
-        <p:spPr>
-          <a:xfrm>
-            <a:off x="1011608" y="0"/>
-            <a:ext cx="7958331" cy="1077229"/>
-          </a:xfrm>
-        </p:spPr>
-        <p:txBody>
-          <a:bodyPr/>
-          <a:lstStyle/>
-          <a:p>
-            <a:pPr algn="ctr"/>
-            <a:r>
-              <a:rPr lang="es-CL" dirty="0"/>
-              <a:t>¿Como Funciona?</a:t>
-            </a:r>
-          </a:p>
-        </p:txBody>
-      </p:sp>
-      <p:sp>
-        <p:nvSpPr>
-          <p:cNvPr id="3" name="Content Placeholder 2">
-            <a:extLst>
-              <a:ext uri="{FF2B5EF4-FFF2-40B4-BE49-F238E27FC236}">
-                <a16:creationId xmlns:a16="http://schemas.microsoft.com/office/drawing/2014/main" id="{0F389008-5F9B-EB0F-8BB0-1D662ECF9C99}"/>
-              </a:ext>
-            </a:extLst>
-          </p:cNvPr>
-          <p:cNvSpPr>
-            <a:spLocks noGrp="1"/>
-          </p:cNvSpPr>
-          <p:nvPr>
-            <p:ph idx="1"/>
-          </p:nvPr>
-        </p:nvSpPr>
-        <p:spPr>
-          <a:xfrm>
-            <a:off x="1011608" y="1077229"/>
-            <a:ext cx="1759024" cy="943595"/>
-          </a:xfrm>
-        </p:spPr>
-        <p:txBody>
-          <a:bodyPr>
-            <a:noAutofit/>
-          </a:bodyPr>
-          <a:lstStyle/>
-          <a:p>
-            <a:pPr marL="0" indent="0">
-              <a:buNone/>
-            </a:pPr>
-            <a:r>
-              <a:rPr lang="es-CL" sz="2500" dirty="0"/>
-              <a:t>Cliente</a:t>
-            </a:r>
-          </a:p>
-        </p:txBody>
-      </p:sp>
-      <p:sp>
-        <p:nvSpPr>
-          <p:cNvPr id="10" name="Arrow: Right 9">
-            <a:extLst>
-              <a:ext uri="{FF2B5EF4-FFF2-40B4-BE49-F238E27FC236}">
-                <a16:creationId xmlns:a16="http://schemas.microsoft.com/office/drawing/2014/main" id="{FEC2E97C-1836-6B62-1415-789AB5BCE105}"/>
-              </a:ext>
-            </a:extLst>
-          </p:cNvPr>
-          <p:cNvSpPr/>
-          <p:nvPr/>
-        </p:nvSpPr>
-        <p:spPr>
-          <a:xfrm>
-            <a:off x="2198256" y="1389006"/>
-            <a:ext cx="850068" cy="362996"/>
-          </a:xfrm>
-          <a:prstGeom prst="rightArrow">
-            <a:avLst/>
-          </a:prstGeom>
-        </p:spPr>
-        <p:style>
-          <a:lnRef idx="2">
-            <a:schemeClr val="dk1"/>
-          </a:lnRef>
-          <a:fillRef idx="1">
-            <a:schemeClr val="lt1"/>
-          </a:fillRef>
-          <a:effectRef idx="0">
-            <a:schemeClr val="dk1"/>
-          </a:effectRef>
-          <a:fontRef idx="minor">
-            <a:schemeClr val="dk1"/>
-          </a:fontRef>
-        </p:style>
-        <p:txBody>
-          <a:bodyPr rtlCol="0" anchor="ctr"/>
-          <a:lstStyle/>
-          <a:p>
-            <a:pPr algn="ctr"/>
-            <a:endParaRPr lang="es-CL" dirty="0"/>
-          </a:p>
-        </p:txBody>
-      </p:sp>
-      <p:sp>
-        <p:nvSpPr>
-          <p:cNvPr id="17" name="TextBox 16">
-            <a:extLst>
-              <a:ext uri="{FF2B5EF4-FFF2-40B4-BE49-F238E27FC236}">
-                <a16:creationId xmlns:a16="http://schemas.microsoft.com/office/drawing/2014/main" id="{0909037C-C07B-CDA5-48E5-A016689338C7}"/>
-              </a:ext>
-            </a:extLst>
-          </p:cNvPr>
-          <p:cNvSpPr txBox="1"/>
-          <p:nvPr/>
-        </p:nvSpPr>
-        <p:spPr>
-          <a:xfrm>
-            <a:off x="3090673" y="1203888"/>
-            <a:ext cx="1792224" cy="861774"/>
-          </a:xfrm>
-          <a:prstGeom prst="rect">
-            <a:avLst/>
-          </a:prstGeom>
-          <a:noFill/>
-        </p:spPr>
-        <p:txBody>
-          <a:bodyPr wrap="square" rtlCol="0">
-            <a:spAutoFit/>
-          </a:bodyPr>
-          <a:lstStyle/>
-          <a:p>
-            <a:r>
-              <a:rPr lang="es-CL" sz="2500" dirty="0"/>
-              <a:t>Buscar servicio</a:t>
-            </a:r>
-          </a:p>
-        </p:txBody>
-      </p:sp>
-      <p:sp>
-        <p:nvSpPr>
-          <p:cNvPr id="18" name="TextBox 17">
-            <a:extLst>
-              <a:ext uri="{FF2B5EF4-FFF2-40B4-BE49-F238E27FC236}">
-                <a16:creationId xmlns:a16="http://schemas.microsoft.com/office/drawing/2014/main" id="{036619D7-9525-044D-E568-3FE894B1C497}"/>
-              </a:ext>
-            </a:extLst>
-          </p:cNvPr>
-          <p:cNvSpPr txBox="1"/>
-          <p:nvPr/>
-        </p:nvSpPr>
-        <p:spPr>
-          <a:xfrm>
-            <a:off x="5307931" y="931803"/>
-            <a:ext cx="2307338" cy="1246495"/>
-          </a:xfrm>
-          <a:prstGeom prst="rect">
-            <a:avLst/>
-          </a:prstGeom>
-          <a:noFill/>
-        </p:spPr>
-        <p:txBody>
-          <a:bodyPr wrap="square" rtlCol="0">
-            <a:spAutoFit/>
-          </a:bodyPr>
-          <a:lstStyle/>
-          <a:p>
-            <a:pPr algn="ctr"/>
-            <a:r>
-              <a:rPr lang="es-CL" sz="2500" dirty="0"/>
-              <a:t>Revisar portafolio </a:t>
-            </a:r>
-          </a:p>
-          <a:p>
-            <a:pPr algn="ctr"/>
-            <a:r>
-              <a:rPr lang="es-CL" sz="2500" dirty="0"/>
-              <a:t>(opcional)</a:t>
-            </a:r>
-          </a:p>
-        </p:txBody>
-      </p:sp>
-      <p:sp>
-        <p:nvSpPr>
-          <p:cNvPr id="23" name="TextBox 22">
-            <a:extLst>
-              <a:ext uri="{FF2B5EF4-FFF2-40B4-BE49-F238E27FC236}">
-                <a16:creationId xmlns:a16="http://schemas.microsoft.com/office/drawing/2014/main" id="{EBDA9ABC-897F-01E2-3019-B997F4409C82}"/>
-              </a:ext>
-            </a:extLst>
-          </p:cNvPr>
-          <p:cNvSpPr txBox="1"/>
-          <p:nvPr/>
-        </p:nvSpPr>
-        <p:spPr>
-          <a:xfrm>
-            <a:off x="8127009" y="1004516"/>
-            <a:ext cx="2346968" cy="1246495"/>
-          </a:xfrm>
-          <a:prstGeom prst="rect">
-            <a:avLst/>
-          </a:prstGeom>
-          <a:noFill/>
-        </p:spPr>
-        <p:txBody>
-          <a:bodyPr wrap="square" rtlCol="0">
-            <a:spAutoFit/>
-          </a:bodyPr>
-          <a:lstStyle/>
-          <a:p>
-            <a:pPr algn="ctr"/>
-            <a:r>
-              <a:rPr lang="es-CL" sz="2500" dirty="0"/>
-              <a:t>Comunicarse y agendar con trabajador</a:t>
-            </a:r>
-          </a:p>
-        </p:txBody>
-      </p:sp>
-      <p:sp>
-        <p:nvSpPr>
-          <p:cNvPr id="25" name="Arrow: Right 24">
-            <a:extLst>
-              <a:ext uri="{FF2B5EF4-FFF2-40B4-BE49-F238E27FC236}">
-                <a16:creationId xmlns:a16="http://schemas.microsoft.com/office/drawing/2014/main" id="{0C59D07D-1A03-60A7-2286-1B0D71CFD5DA}"/>
-              </a:ext>
-            </a:extLst>
-          </p:cNvPr>
-          <p:cNvSpPr/>
-          <p:nvPr/>
-        </p:nvSpPr>
-        <p:spPr>
-          <a:xfrm>
-            <a:off x="4457863" y="1389006"/>
-            <a:ext cx="850068" cy="362996"/>
-          </a:xfrm>
-          <a:prstGeom prst="rightArrow">
-            <a:avLst/>
-          </a:prstGeom>
-        </p:spPr>
-        <p:style>
-          <a:lnRef idx="2">
-            <a:schemeClr val="dk1"/>
-          </a:lnRef>
-          <a:fillRef idx="1">
-            <a:schemeClr val="lt1"/>
-          </a:fillRef>
-          <a:effectRef idx="0">
-            <a:schemeClr val="dk1"/>
-          </a:effectRef>
-          <a:fontRef idx="minor">
-            <a:schemeClr val="dk1"/>
-          </a:fontRef>
-        </p:style>
-        <p:txBody>
-          <a:bodyPr rtlCol="0" anchor="ctr"/>
-          <a:lstStyle/>
-          <a:p>
-            <a:pPr algn="ctr"/>
-            <a:endParaRPr lang="es-CL" dirty="0"/>
-          </a:p>
-        </p:txBody>
-      </p:sp>
-      <p:sp>
-        <p:nvSpPr>
-          <p:cNvPr id="27" name="Arrow: Right 26">
-            <a:extLst>
-              <a:ext uri="{FF2B5EF4-FFF2-40B4-BE49-F238E27FC236}">
-                <a16:creationId xmlns:a16="http://schemas.microsoft.com/office/drawing/2014/main" id="{6F445022-5CFD-BA68-330F-7CC2264B08DA}"/>
-              </a:ext>
-            </a:extLst>
-          </p:cNvPr>
-          <p:cNvSpPr/>
-          <p:nvPr/>
-        </p:nvSpPr>
-        <p:spPr>
-          <a:xfrm>
-            <a:off x="7276941" y="1459099"/>
-            <a:ext cx="850068" cy="362996"/>
-          </a:xfrm>
-          <a:prstGeom prst="rightArrow">
-            <a:avLst/>
-          </a:prstGeom>
-        </p:spPr>
-        <p:style>
-          <a:lnRef idx="2">
-            <a:schemeClr val="dk1"/>
-          </a:lnRef>
-          <a:fillRef idx="1">
-            <a:schemeClr val="lt1"/>
-          </a:fillRef>
-          <a:effectRef idx="0">
-            <a:schemeClr val="dk1"/>
-          </a:effectRef>
-          <a:fontRef idx="minor">
-            <a:schemeClr val="dk1"/>
-          </a:fontRef>
-        </p:style>
-        <p:txBody>
-          <a:bodyPr rtlCol="0" anchor="ctr"/>
-          <a:lstStyle/>
-          <a:p>
-            <a:pPr algn="ctr"/>
-            <a:endParaRPr lang="es-CL" dirty="0"/>
-          </a:p>
-        </p:txBody>
-      </p:sp>
-      <p:sp>
-        <p:nvSpPr>
-          <p:cNvPr id="28" name="Content Placeholder 2">
-            <a:extLst>
-              <a:ext uri="{FF2B5EF4-FFF2-40B4-BE49-F238E27FC236}">
-                <a16:creationId xmlns:a16="http://schemas.microsoft.com/office/drawing/2014/main" id="{D5244551-72EA-1EF3-9371-29E0F0D75030}"/>
-              </a:ext>
-            </a:extLst>
-          </p:cNvPr>
-          <p:cNvSpPr txBox="1">
-            <a:spLocks/>
-          </p:cNvSpPr>
-          <p:nvPr/>
-        </p:nvSpPr>
-        <p:spPr>
-          <a:xfrm>
-            <a:off x="1100000" y="2485405"/>
-            <a:ext cx="1759024" cy="943595"/>
-          </a:xfrm>
-          <a:prstGeom prst="rect">
-            <a:avLst/>
-          </a:prstGeom>
-        </p:spPr>
-        <p:txBody>
-          <a:bodyPr vert="horz" lIns="91440" tIns="45720" rIns="91440" bIns="45720" rtlCol="0" anchor="ctr">
-            <a:noAutofit/>
-          </a:bodyPr>
-          <a:lstStyle>
-            <a:lvl1pPr marL="344488" indent="-344488" algn="l" defTabSz="914400" rtl="0" eaLnBrk="1" latinLnBrk="0" hangingPunct="1">
-              <a:lnSpc>
-                <a:spcPct val="120000"/>
-              </a:lnSpc>
-              <a:spcBef>
-                <a:spcPts val="1000"/>
-              </a:spcBef>
-              <a:spcAft>
-                <a:spcPts val="600"/>
-              </a:spcAft>
-              <a:buClr>
-                <a:schemeClr val="accent6"/>
-              </a:buClr>
-              <a:buSzPct val="90000"/>
-              <a:buFont typeface="Wingdings" panose="05000000000000000000" pitchFamily="2" charset="2"/>
-              <a:buChar char="§"/>
-              <a:defRPr sz="2000" kern="1200">
-                <a:solidFill>
-                  <a:schemeClr val="tx1"/>
-                </a:solidFill>
-                <a:effectLst/>
-                <a:latin typeface="+mn-lt"/>
-                <a:ea typeface="+mn-ea"/>
-                <a:cs typeface="+mn-cs"/>
-              </a:defRPr>
-            </a:lvl1pPr>
-            <a:lvl2pPr marL="795338" indent="-338138" algn="l" defTabSz="914400" rtl="0" eaLnBrk="1" latinLnBrk="0" hangingPunct="1">
-              <a:lnSpc>
-                <a:spcPct val="120000"/>
-              </a:lnSpc>
-              <a:spcBef>
-                <a:spcPts val="500"/>
-              </a:spcBef>
-              <a:spcAft>
-                <a:spcPts val="600"/>
-              </a:spcAft>
-              <a:buClr>
-                <a:schemeClr val="accent6"/>
-              </a:buClr>
-              <a:buSzPct val="90000"/>
-              <a:buFont typeface="Wingdings" panose="05000000000000000000" pitchFamily="2" charset="2"/>
-              <a:buChar char="§"/>
-              <a:defRPr sz="1800" kern="1200">
-                <a:solidFill>
-                  <a:schemeClr val="tx1"/>
-                </a:solidFill>
-                <a:effectLst/>
-                <a:latin typeface="+mn-lt"/>
-                <a:ea typeface="+mn-ea"/>
-                <a:cs typeface="+mn-cs"/>
-              </a:defRPr>
-            </a:lvl2pPr>
-            <a:lvl3pPr marL="1258888" indent="-344488" algn="l" defTabSz="914400" rtl="0" eaLnBrk="1" latinLnBrk="0" hangingPunct="1">
-              <a:lnSpc>
-                <a:spcPct val="120000"/>
-              </a:lnSpc>
-              <a:spcBef>
-                <a:spcPts val="500"/>
-              </a:spcBef>
-              <a:spcAft>
-                <a:spcPts val="600"/>
-              </a:spcAft>
-              <a:buClr>
-                <a:schemeClr val="accent6"/>
-              </a:buClr>
-              <a:buSzPct val="90000"/>
-              <a:buFont typeface="Wingdings" panose="05000000000000000000" pitchFamily="2" charset="2"/>
-              <a:buChar char="§"/>
-              <a:defRPr sz="1600" kern="1200">
-                <a:solidFill>
-                  <a:schemeClr val="tx1"/>
-                </a:solidFill>
-                <a:effectLst/>
-                <a:latin typeface="+mn-lt"/>
-                <a:ea typeface="+mn-ea"/>
-                <a:cs typeface="+mn-cs"/>
-              </a:defRPr>
-            </a:lvl3pPr>
-            <a:lvl4pPr marL="1709738" indent="-338138" algn="l" defTabSz="914400" rtl="0" eaLnBrk="1" latinLnBrk="0" hangingPunct="1">
-              <a:lnSpc>
-                <a:spcPct val="120000"/>
-              </a:lnSpc>
-              <a:spcBef>
-                <a:spcPts val="500"/>
-              </a:spcBef>
-              <a:spcAft>
-                <a:spcPts val="600"/>
-              </a:spcAft>
-              <a:buClr>
-                <a:schemeClr val="accent6"/>
-              </a:buClr>
-              <a:buSzPct val="90000"/>
-              <a:buFont typeface="Wingdings" panose="05000000000000000000" pitchFamily="2" charset="2"/>
-              <a:buChar char="§"/>
-              <a:defRPr sz="1400" kern="1200">
-                <a:solidFill>
-                  <a:schemeClr val="tx1"/>
-                </a:solidFill>
-                <a:effectLst/>
-                <a:latin typeface="+mn-lt"/>
-                <a:ea typeface="+mn-ea"/>
-                <a:cs typeface="+mn-cs"/>
-              </a:defRPr>
-            </a:lvl4pPr>
-            <a:lvl5pPr marL="2173288" indent="-344488" algn="l" defTabSz="914400" rtl="0" eaLnBrk="1" latinLnBrk="0" hangingPunct="1">
-              <a:lnSpc>
-                <a:spcPct val="120000"/>
-              </a:lnSpc>
-              <a:spcBef>
-                <a:spcPts val="500"/>
-              </a:spcBef>
-              <a:spcAft>
-                <a:spcPts val="600"/>
-              </a:spcAft>
-              <a:buClr>
-                <a:schemeClr val="accent6"/>
-              </a:buClr>
-              <a:buSzPct val="90000"/>
-              <a:buFont typeface="Wingdings" panose="05000000000000000000" pitchFamily="2" charset="2"/>
-              <a:buChar char="§"/>
-              <a:defRPr sz="1200" kern="1200">
-                <a:solidFill>
-                  <a:schemeClr val="tx1"/>
-                </a:solidFill>
-                <a:effectLst/>
-                <a:latin typeface="+mn-lt"/>
-                <a:ea typeface="+mn-ea"/>
-                <a:cs typeface="+mn-cs"/>
-              </a:defRPr>
-            </a:lvl5pPr>
-            <a:lvl6pPr marL="2642616" indent="-338328" algn="l" defTabSz="914400" rtl="0" eaLnBrk="1" latinLnBrk="0" hangingPunct="1">
-              <a:lnSpc>
-                <a:spcPct val="120000"/>
-              </a:lnSpc>
-              <a:spcBef>
-                <a:spcPts val="500"/>
-              </a:spcBef>
-              <a:spcAft>
-                <a:spcPts val="600"/>
-              </a:spcAft>
-              <a:buClr>
-                <a:schemeClr val="accent6"/>
-              </a:buClr>
-              <a:buSzPct val="90000"/>
-              <a:buFont typeface="Wingdings" panose="05000000000000000000" pitchFamily="2" charset="2"/>
-              <a:buChar char="§"/>
-              <a:defRPr sz="1200" kern="1200" baseline="0">
-                <a:solidFill>
-                  <a:schemeClr val="tx1"/>
-                </a:solidFill>
-                <a:effectLst/>
-                <a:latin typeface="+mn-lt"/>
-                <a:ea typeface="+mn-ea"/>
-                <a:cs typeface="+mn-cs"/>
-              </a:defRPr>
-            </a:lvl6pPr>
-            <a:lvl7pPr marL="3108960" indent="-338328" algn="l" defTabSz="914400" rtl="0" eaLnBrk="1" latinLnBrk="0" hangingPunct="1">
-              <a:lnSpc>
-                <a:spcPct val="120000"/>
-              </a:lnSpc>
-              <a:spcBef>
-                <a:spcPts val="500"/>
-              </a:spcBef>
-              <a:spcAft>
-                <a:spcPts val="600"/>
-              </a:spcAft>
-              <a:buClr>
-                <a:schemeClr val="accent6"/>
-              </a:buClr>
-              <a:buSzPct val="90000"/>
-              <a:buFont typeface="Wingdings" panose="05000000000000000000" pitchFamily="2" charset="2"/>
-              <a:buChar char="§"/>
-              <a:defRPr sz="1200" kern="1200" baseline="0">
-                <a:solidFill>
-                  <a:schemeClr val="tx1"/>
-                </a:solidFill>
-                <a:effectLst/>
-                <a:latin typeface="+mn-lt"/>
-                <a:ea typeface="+mn-ea"/>
-                <a:cs typeface="+mn-cs"/>
-              </a:defRPr>
-            </a:lvl7pPr>
-            <a:lvl8pPr marL="3575304" indent="-338328" algn="l" defTabSz="914400" rtl="0" eaLnBrk="1" latinLnBrk="0" hangingPunct="1">
-              <a:lnSpc>
-                <a:spcPct val="120000"/>
-              </a:lnSpc>
-              <a:spcBef>
-                <a:spcPts val="500"/>
-              </a:spcBef>
-              <a:spcAft>
-                <a:spcPts val="600"/>
-              </a:spcAft>
-              <a:buClr>
-                <a:schemeClr val="accent6"/>
-              </a:buClr>
-              <a:buSzPct val="90000"/>
-              <a:buFont typeface="Wingdings" panose="05000000000000000000" pitchFamily="2" charset="2"/>
-              <a:buChar char="§"/>
-              <a:defRPr sz="1200" kern="1200" baseline="0">
-                <a:solidFill>
-                  <a:schemeClr val="tx1"/>
-                </a:solidFill>
-                <a:effectLst/>
-                <a:latin typeface="+mn-lt"/>
-                <a:ea typeface="+mn-ea"/>
-                <a:cs typeface="+mn-cs"/>
-              </a:defRPr>
-            </a:lvl8pPr>
-            <a:lvl9pPr marL="4041648" indent="-338328" algn="l" defTabSz="914400" rtl="0" eaLnBrk="1" latinLnBrk="0" hangingPunct="1">
-              <a:lnSpc>
-                <a:spcPct val="120000"/>
-              </a:lnSpc>
-              <a:spcBef>
-                <a:spcPts val="500"/>
-              </a:spcBef>
-              <a:spcAft>
-                <a:spcPts val="600"/>
-              </a:spcAft>
-              <a:buClr>
-                <a:schemeClr val="accent6"/>
-              </a:buClr>
-              <a:buSzPct val="90000"/>
-              <a:buFont typeface="Wingdings" panose="05000000000000000000" pitchFamily="2" charset="2"/>
-              <a:buChar char="§"/>
-              <a:defRPr sz="1200" kern="1200" baseline="0">
-                <a:solidFill>
-                  <a:schemeClr val="tx1"/>
-                </a:solidFill>
-                <a:effectLst/>
-                <a:latin typeface="+mn-lt"/>
-                <a:ea typeface="+mn-ea"/>
-                <a:cs typeface="+mn-cs"/>
-              </a:defRPr>
-            </a:lvl9pPr>
-          </a:lstStyle>
-          <a:p>
-            <a:pPr marL="0" indent="0">
-              <a:buFont typeface="Wingdings" panose="05000000000000000000" pitchFamily="2" charset="2"/>
-              <a:buNone/>
-            </a:pPr>
-            <a:r>
-              <a:rPr lang="es-CL" sz="2500" dirty="0"/>
-              <a:t>Trabajador</a:t>
-            </a:r>
-          </a:p>
-        </p:txBody>
-      </p:sp>
-      <p:sp>
-        <p:nvSpPr>
-          <p:cNvPr id="30" name="Arrow: Right 29">
-            <a:extLst>
-              <a:ext uri="{FF2B5EF4-FFF2-40B4-BE49-F238E27FC236}">
-                <a16:creationId xmlns:a16="http://schemas.microsoft.com/office/drawing/2014/main" id="{D20DBEA2-834F-BF89-1748-751E54B5BAC5}"/>
-              </a:ext>
-            </a:extLst>
-          </p:cNvPr>
-          <p:cNvSpPr/>
-          <p:nvPr/>
-        </p:nvSpPr>
-        <p:spPr>
-          <a:xfrm>
-            <a:off x="2865120" y="2804563"/>
-            <a:ext cx="609600" cy="362996"/>
-          </a:xfrm>
-          <a:prstGeom prst="rightArrow">
-            <a:avLst/>
-          </a:prstGeom>
-        </p:spPr>
-        <p:style>
-          <a:lnRef idx="2">
-            <a:schemeClr val="dk1"/>
-          </a:lnRef>
-          <a:fillRef idx="1">
-            <a:schemeClr val="lt1"/>
-          </a:fillRef>
-          <a:effectRef idx="0">
-            <a:schemeClr val="dk1"/>
-          </a:effectRef>
-          <a:fontRef idx="minor">
-            <a:schemeClr val="dk1"/>
-          </a:fontRef>
-        </p:style>
-        <p:txBody>
-          <a:bodyPr rtlCol="0" anchor="ctr"/>
-          <a:lstStyle/>
-          <a:p>
-            <a:pPr algn="ctr"/>
-            <a:endParaRPr lang="es-CL" dirty="0"/>
-          </a:p>
-        </p:txBody>
-      </p:sp>
-      <p:sp>
-        <p:nvSpPr>
-          <p:cNvPr id="32" name="TextBox 31">
-            <a:extLst>
-              <a:ext uri="{FF2B5EF4-FFF2-40B4-BE49-F238E27FC236}">
-                <a16:creationId xmlns:a16="http://schemas.microsoft.com/office/drawing/2014/main" id="{700499C2-66CA-B9C8-29FA-D0EE8582081B}"/>
-              </a:ext>
-            </a:extLst>
-          </p:cNvPr>
-          <p:cNvSpPr txBox="1"/>
-          <p:nvPr/>
-        </p:nvSpPr>
-        <p:spPr>
-          <a:xfrm>
-            <a:off x="3520442" y="2555174"/>
-            <a:ext cx="1792224" cy="861774"/>
-          </a:xfrm>
-          <a:prstGeom prst="rect">
-            <a:avLst/>
-          </a:prstGeom>
-          <a:noFill/>
-        </p:spPr>
-        <p:txBody>
-          <a:bodyPr wrap="square" rtlCol="0">
-            <a:spAutoFit/>
-          </a:bodyPr>
-          <a:lstStyle/>
-          <a:p>
-            <a:r>
-              <a:rPr lang="es-CL" sz="2500" dirty="0"/>
-              <a:t>Crear perfil acorde</a:t>
-            </a:r>
-          </a:p>
-        </p:txBody>
-      </p:sp>
-      <p:sp>
-        <p:nvSpPr>
-          <p:cNvPr id="34" name="Arrow: Right 33">
-            <a:extLst>
-              <a:ext uri="{FF2B5EF4-FFF2-40B4-BE49-F238E27FC236}">
-                <a16:creationId xmlns:a16="http://schemas.microsoft.com/office/drawing/2014/main" id="{4020A8C8-65BB-DA4F-BB7C-1CB4FD15EAAE}"/>
-              </a:ext>
-            </a:extLst>
-          </p:cNvPr>
-          <p:cNvSpPr/>
-          <p:nvPr/>
-        </p:nvSpPr>
-        <p:spPr>
-          <a:xfrm>
-            <a:off x="5364484" y="2760498"/>
-            <a:ext cx="609600" cy="451125"/>
-          </a:xfrm>
-          <a:prstGeom prst="rightArrow">
-            <a:avLst/>
-          </a:prstGeom>
-        </p:spPr>
-        <p:style>
-          <a:lnRef idx="2">
-            <a:schemeClr val="dk1"/>
-          </a:lnRef>
-          <a:fillRef idx="1">
-            <a:schemeClr val="lt1"/>
-          </a:fillRef>
-          <a:effectRef idx="0">
-            <a:schemeClr val="dk1"/>
-          </a:effectRef>
-          <a:fontRef idx="minor">
-            <a:schemeClr val="dk1"/>
-          </a:fontRef>
-        </p:style>
-        <p:txBody>
-          <a:bodyPr rtlCol="0" anchor="ctr"/>
-          <a:lstStyle/>
-          <a:p>
-            <a:pPr algn="ctr"/>
-            <a:endParaRPr lang="es-CL" dirty="0"/>
-          </a:p>
-        </p:txBody>
-      </p:sp>
-      <p:sp>
-        <p:nvSpPr>
-          <p:cNvPr id="36" name="TextBox 35">
-            <a:extLst>
-              <a:ext uri="{FF2B5EF4-FFF2-40B4-BE49-F238E27FC236}">
-                <a16:creationId xmlns:a16="http://schemas.microsoft.com/office/drawing/2014/main" id="{5A781339-C3D6-6C47-A4E7-CEF4A115450C}"/>
-              </a:ext>
-            </a:extLst>
-          </p:cNvPr>
-          <p:cNvSpPr txBox="1"/>
-          <p:nvPr/>
-        </p:nvSpPr>
-        <p:spPr>
-          <a:xfrm>
-            <a:off x="5669284" y="2575049"/>
-            <a:ext cx="2307338" cy="861774"/>
-          </a:xfrm>
-          <a:prstGeom prst="rect">
-            <a:avLst/>
-          </a:prstGeom>
-          <a:noFill/>
-        </p:spPr>
-        <p:txBody>
-          <a:bodyPr wrap="square" rtlCol="0">
-            <a:spAutoFit/>
-          </a:bodyPr>
-          <a:lstStyle/>
-          <a:p>
-            <a:pPr algn="ctr"/>
-            <a:r>
-              <a:rPr lang="es-CL" sz="2500" dirty="0"/>
-              <a:t>Publicar portafolio</a:t>
-            </a:r>
-          </a:p>
-        </p:txBody>
-      </p:sp>
-      <p:sp>
-        <p:nvSpPr>
-          <p:cNvPr id="40" name="Arrow: Right 39">
-            <a:extLst>
-              <a:ext uri="{FF2B5EF4-FFF2-40B4-BE49-F238E27FC236}">
-                <a16:creationId xmlns:a16="http://schemas.microsoft.com/office/drawing/2014/main" id="{D867C3DF-6842-FD68-51D4-CBC2DFBAE539}"/>
-              </a:ext>
-            </a:extLst>
-          </p:cNvPr>
-          <p:cNvSpPr/>
-          <p:nvPr/>
-        </p:nvSpPr>
-        <p:spPr>
-          <a:xfrm>
-            <a:off x="7615269" y="2760497"/>
-            <a:ext cx="609600" cy="451125"/>
-          </a:xfrm>
-          <a:prstGeom prst="rightArrow">
-            <a:avLst/>
-          </a:prstGeom>
-        </p:spPr>
-        <p:style>
-          <a:lnRef idx="2">
-            <a:schemeClr val="dk1"/>
-          </a:lnRef>
-          <a:fillRef idx="1">
-            <a:schemeClr val="lt1"/>
-          </a:fillRef>
-          <a:effectRef idx="0">
-            <a:schemeClr val="dk1"/>
-          </a:effectRef>
-          <a:fontRef idx="minor">
-            <a:schemeClr val="dk1"/>
-          </a:fontRef>
-        </p:style>
-        <p:txBody>
-          <a:bodyPr rtlCol="0" anchor="ctr"/>
-          <a:lstStyle/>
-          <a:p>
-            <a:pPr algn="ctr"/>
-            <a:endParaRPr lang="es-CL" dirty="0"/>
-          </a:p>
-        </p:txBody>
-      </p:sp>
-      <p:sp>
-        <p:nvSpPr>
-          <p:cNvPr id="42" name="TextBox 41">
-            <a:extLst>
-              <a:ext uri="{FF2B5EF4-FFF2-40B4-BE49-F238E27FC236}">
-                <a16:creationId xmlns:a16="http://schemas.microsoft.com/office/drawing/2014/main" id="{63BEF7A7-3D2C-191F-2C30-09CF7EFD018C}"/>
-              </a:ext>
-            </a:extLst>
-          </p:cNvPr>
-          <p:cNvSpPr txBox="1"/>
-          <p:nvPr/>
-        </p:nvSpPr>
-        <p:spPr>
-          <a:xfrm>
-            <a:off x="7976622" y="2454414"/>
-            <a:ext cx="2307338" cy="1246495"/>
-          </a:xfrm>
-          <a:prstGeom prst="rect">
-            <a:avLst/>
-          </a:prstGeom>
-          <a:noFill/>
-        </p:spPr>
-        <p:txBody>
-          <a:bodyPr wrap="square" rtlCol="0">
-            <a:spAutoFit/>
-          </a:bodyPr>
-          <a:lstStyle/>
-          <a:p>
-            <a:pPr algn="ctr"/>
-            <a:r>
-              <a:rPr lang="es-CL" sz="2500" dirty="0"/>
-              <a:t>Gestionar reservas y esperar</a:t>
-            </a:r>
-          </a:p>
-        </p:txBody>
-      </p:sp>
-      <p:pic>
-        <p:nvPicPr>
-          <p:cNvPr id="45" name="Picture 44" descr="Agenda - Iconos gratis de herramientas y utensilios">
-            <a:extLst>
-              <a:ext uri="{FF2B5EF4-FFF2-40B4-BE49-F238E27FC236}">
-                <a16:creationId xmlns:a16="http://schemas.microsoft.com/office/drawing/2014/main" id="{F1980E9D-F53B-8E8D-B2FA-FC9B34A510A1}"/>
-              </a:ext>
-            </a:extLst>
-          </p:cNvPr>
-          <p:cNvPicPr>
-            <a:picLocks noChangeAspect="1"/>
-          </p:cNvPicPr>
-          <p:nvPr/>
-        </p:nvPicPr>
-        <p:blipFill>
-          <a:blip r:embed="rId2"/>
-          <a:stretch>
-            <a:fillRect/>
-          </a:stretch>
-        </p:blipFill>
-        <p:spPr>
-          <a:xfrm>
-            <a:off x="6822953" y="4550437"/>
-            <a:ext cx="1696928" cy="1696928"/>
-          </a:xfrm>
-          <a:prstGeom prst="rect">
-            <a:avLst/>
-          </a:prstGeom>
-        </p:spPr>
-      </p:pic>
-      <p:pic>
-        <p:nvPicPr>
-          <p:cNvPr id="46" name="Picture 45" descr="Handshake Transparent PNG Clip Art Image​ | Gallery Yopriceville -  High-Quality Free Images and Transparent PNG Clipart">
-            <a:extLst>
-              <a:ext uri="{FF2B5EF4-FFF2-40B4-BE49-F238E27FC236}">
-                <a16:creationId xmlns:a16="http://schemas.microsoft.com/office/drawing/2014/main" id="{8FA597C4-2180-E4C7-283C-5521E1CEB5F9}"/>
-              </a:ext>
-            </a:extLst>
-          </p:cNvPr>
-          <p:cNvPicPr>
-            <a:picLocks noChangeAspect="1"/>
-          </p:cNvPicPr>
-          <p:nvPr/>
-        </p:nvPicPr>
-        <p:blipFill>
-          <a:blip r:embed="rId3"/>
-          <a:stretch>
-            <a:fillRect/>
-          </a:stretch>
-        </p:blipFill>
-        <p:spPr>
-          <a:xfrm>
-            <a:off x="3607472" y="4550437"/>
-            <a:ext cx="2550850" cy="1545496"/>
-          </a:xfrm>
-          <a:prstGeom prst="rect">
-            <a:avLst/>
-          </a:prstGeom>
-        </p:spPr>
-      </p:pic>
-    </p:spTree>
-    <p:extLst>
-      <p:ext uri="{BB962C8B-B14F-4D97-AF65-F5344CB8AC3E}">
-        <p14:creationId xmlns:p14="http://schemas.microsoft.com/office/powerpoint/2010/main" val="1935738994"/>
-      </p:ext>
-    </p:extLst>
-  </p:cSld>
-  <p:clrMapOvr>
-    <a:masterClrMapping/>
-  </p:clrMapOvr>
-</p:sld>
-</file>
-
-<file path=ppt/slides/slide5.xml><?xml version="1.0" encoding="utf-8"?>
-<p:sld xmlns:a="http://schemas.openxmlformats.org/drawingml/2006/main" xmlns:r="http://schemas.openxmlformats.org/officeDocument/2006/relationships" xmlns:p="http://schemas.openxmlformats.org/presentationml/2006/main">
-  <p:cSld>
-    <p:spTree>
-      <p:nvGrpSpPr>
-        <p:cNvPr id="1" name="">
-          <a:extLst>
-            <a:ext uri="{FF2B5EF4-FFF2-40B4-BE49-F238E27FC236}">
-              <a16:creationId xmlns:a16="http://schemas.microsoft.com/office/drawing/2014/main" id="{1F85061C-5F5E-42F4-0034-1DD4CE968F98}"/>
-            </a:ext>
-          </a:extLst>
-        </p:cNvPr>
-        <p:cNvGrpSpPr/>
-        <p:nvPr/>
-      </p:nvGrpSpPr>
-      <p:grpSpPr>
-        <a:xfrm>
-          <a:off x="0" y="0"/>
-          <a:ext cx="0" cy="0"/>
-          <a:chOff x="0" y="0"/>
-          <a:chExt cx="0" cy="0"/>
-        </a:xfrm>
-      </p:grpSpPr>
-      <p:sp>
-        <p:nvSpPr>
-          <p:cNvPr id="2" name="Title 1">
-            <a:extLst>
-              <a:ext uri="{FF2B5EF4-FFF2-40B4-BE49-F238E27FC236}">
-                <a16:creationId xmlns:a16="http://schemas.microsoft.com/office/drawing/2014/main" id="{1728A193-A30F-0FFF-D5FD-C1431E564B24}"/>
-              </a:ext>
-            </a:extLst>
-          </p:cNvPr>
-          <p:cNvSpPr>
-            <a:spLocks noGrp="1"/>
-          </p:cNvSpPr>
-          <p:nvPr>
-            <p:ph type="title"/>
-          </p:nvPr>
-        </p:nvSpPr>
-        <p:spPr>
-          <a:xfrm>
-            <a:off x="1011608" y="0"/>
-            <a:ext cx="7958331" cy="1077229"/>
-          </a:xfrm>
-        </p:spPr>
-        <p:txBody>
-          <a:bodyPr/>
-          <a:lstStyle/>
-          <a:p>
-            <a:pPr algn="l"/>
-            <a:r>
-              <a:rPr lang="es-CL" dirty="0"/>
-              <a:t>Funcionalidades</a:t>
-            </a:r>
-          </a:p>
-        </p:txBody>
-      </p:sp>
-      <p:sp>
-        <p:nvSpPr>
-          <p:cNvPr id="3" name="Content Placeholder 2">
-            <a:extLst>
-              <a:ext uri="{FF2B5EF4-FFF2-40B4-BE49-F238E27FC236}">
-                <a16:creationId xmlns:a16="http://schemas.microsoft.com/office/drawing/2014/main" id="{086F52BB-8EB8-A797-069E-6BBD27B389F1}"/>
-              </a:ext>
-            </a:extLst>
-          </p:cNvPr>
-          <p:cNvSpPr>
-            <a:spLocks noGrp="1"/>
-          </p:cNvSpPr>
-          <p:nvPr>
-            <p:ph idx="1"/>
-          </p:nvPr>
-        </p:nvSpPr>
-        <p:spPr>
-          <a:xfrm>
-            <a:off x="1011609" y="1077229"/>
-            <a:ext cx="4730823" cy="4729211"/>
-          </a:xfrm>
-        </p:spPr>
-        <p:txBody>
-          <a:bodyPr>
-            <a:normAutofit/>
-          </a:bodyPr>
-          <a:lstStyle/>
-          <a:p>
-            <a:r>
-              <a:rPr lang="es-CL" dirty="0"/>
-              <a:t>Registro e inicio de sesión</a:t>
-            </a:r>
-          </a:p>
-          <a:p>
-            <a:r>
-              <a:rPr lang="es-CL" dirty="0"/>
-              <a:t>Perfil de trabajador</a:t>
-            </a:r>
-          </a:p>
-          <a:p>
-            <a:r>
-              <a:rPr lang="es-CL" dirty="0"/>
-              <a:t>Portafolio publico</a:t>
-            </a:r>
-          </a:p>
-          <a:p>
-            <a:r>
-              <a:rPr lang="es-CL" dirty="0"/>
-              <a:t>Búsqueda de servicios, categorías y subcategorías</a:t>
-            </a:r>
-          </a:p>
-          <a:p>
-            <a:r>
-              <a:rPr lang="es-CL" dirty="0"/>
-              <a:t>Sistema de reservas</a:t>
-            </a:r>
-          </a:p>
-          <a:p>
-            <a:r>
-              <a:rPr lang="es-CL" dirty="0"/>
-              <a:t>Gestión de reservas</a:t>
-            </a:r>
-          </a:p>
-          <a:p>
-            <a:r>
-              <a:rPr lang="es-CL" dirty="0"/>
-              <a:t>Panel de administración</a:t>
-            </a:r>
-          </a:p>
-        </p:txBody>
-      </p:sp>
-    </p:spTree>
-    <p:extLst>
-      <p:ext uri="{BB962C8B-B14F-4D97-AF65-F5344CB8AC3E}">
-        <p14:creationId xmlns:p14="http://schemas.microsoft.com/office/powerpoint/2010/main" val="907474803"/>
-      </p:ext>
-    </p:extLst>
-  </p:cSld>
-  <p:clrMapOvr>
-    <a:masterClrMapping/>
-  </p:clrMapOvr>
-</p:sld>
-</file>
-
-<file path=ppt/slides/slide6.xml><?xml version="1.0" encoding="utf-8"?>
-<p:sld xmlns:a="http://schemas.openxmlformats.org/drawingml/2006/main" xmlns:r="http://schemas.openxmlformats.org/officeDocument/2006/relationships" xmlns:p="http://schemas.openxmlformats.org/presentationml/2006/main">
-  <p:cSld>
-    <p:spTree>
-      <p:nvGrpSpPr>
-        <p:cNvPr id="1" name="">
-          <a:extLst>
-            <a:ext uri="{FF2B5EF4-FFF2-40B4-BE49-F238E27FC236}">
-              <a16:creationId xmlns:a16="http://schemas.microsoft.com/office/drawing/2014/main" id="{A292DC2B-5D1F-335D-11EF-F086FA17F310}"/>
-            </a:ext>
-          </a:extLst>
-        </p:cNvPr>
-        <p:cNvGrpSpPr/>
-        <p:nvPr/>
-      </p:nvGrpSpPr>
-      <p:grpSpPr>
-        <a:xfrm>
-          <a:off x="0" y="0"/>
-          <a:ext cx="0" cy="0"/>
-          <a:chOff x="0" y="0"/>
-          <a:chExt cx="0" cy="0"/>
-        </a:xfrm>
-      </p:grpSpPr>
-      <p:sp>
-        <p:nvSpPr>
-          <p:cNvPr id="2" name="Title 1">
-            <a:extLst>
-              <a:ext uri="{FF2B5EF4-FFF2-40B4-BE49-F238E27FC236}">
-                <a16:creationId xmlns:a16="http://schemas.microsoft.com/office/drawing/2014/main" id="{A5A6AF27-E566-55D0-D52F-9A542CA9AAAA}"/>
-              </a:ext>
-            </a:extLst>
-          </p:cNvPr>
-          <p:cNvSpPr>
-            <a:spLocks noGrp="1"/>
-          </p:cNvSpPr>
-          <p:nvPr>
-            <p:ph type="title"/>
-          </p:nvPr>
-        </p:nvSpPr>
-        <p:spPr>
-          <a:xfrm>
-            <a:off x="1011608" y="0"/>
-            <a:ext cx="7958331" cy="1077229"/>
-          </a:xfrm>
-        </p:spPr>
-        <p:txBody>
-          <a:bodyPr/>
-          <a:lstStyle/>
-          <a:p>
-            <a:pPr algn="l"/>
-            <a:r>
-              <a:rPr lang="es-CL" dirty="0"/>
-              <a:t>Objetivos</a:t>
-            </a:r>
-          </a:p>
-        </p:txBody>
-      </p:sp>
-      <p:sp>
-        <p:nvSpPr>
-          <p:cNvPr id="3" name="Content Placeholder 2">
-            <a:extLst>
-              <a:ext uri="{FF2B5EF4-FFF2-40B4-BE49-F238E27FC236}">
-                <a16:creationId xmlns:a16="http://schemas.microsoft.com/office/drawing/2014/main" id="{428EC144-0867-9DBD-953A-CBE7D1EB0050}"/>
-              </a:ext>
-            </a:extLst>
-          </p:cNvPr>
-          <p:cNvSpPr>
-            <a:spLocks noGrp="1"/>
-          </p:cNvSpPr>
-          <p:nvPr>
-            <p:ph idx="1"/>
-          </p:nvPr>
-        </p:nvSpPr>
-        <p:spPr>
-          <a:xfrm>
-            <a:off x="1078992" y="720613"/>
-            <a:ext cx="5361759" cy="2242043"/>
-          </a:xfrm>
-        </p:spPr>
-        <p:txBody>
-          <a:bodyPr>
-            <a:normAutofit/>
-          </a:bodyPr>
-          <a:lstStyle/>
-          <a:p>
-            <a:pPr marL="0" indent="0">
-              <a:buNone/>
-            </a:pPr>
-            <a:r>
-              <a:rPr lang="es-CL" dirty="0"/>
-              <a:t>Se busca desarrollar una plataforma que permita a trabajadores independientes administrar un perfil profesional, exponer su portafolio y gestionar reservas de clientes desde su perfil de trabajador.</a:t>
-            </a:r>
-          </a:p>
-        </p:txBody>
-      </p:sp>
-      <p:sp>
-        <p:nvSpPr>
-          <p:cNvPr id="4" name="TextBox 3">
-            <a:extLst>
-              <a:ext uri="{FF2B5EF4-FFF2-40B4-BE49-F238E27FC236}">
-                <a16:creationId xmlns:a16="http://schemas.microsoft.com/office/drawing/2014/main" id="{1C0EF45C-9F67-2E11-C02A-0C20DBDFA8E9}"/>
-              </a:ext>
-            </a:extLst>
-          </p:cNvPr>
-          <p:cNvSpPr txBox="1"/>
-          <p:nvPr/>
-        </p:nvSpPr>
-        <p:spPr>
-          <a:xfrm>
-            <a:off x="1078992" y="3236976"/>
-            <a:ext cx="6528816" cy="3447098"/>
-          </a:xfrm>
-          <a:prstGeom prst="rect">
-            <a:avLst/>
-          </a:prstGeom>
-          <a:noFill/>
-        </p:spPr>
-        <p:txBody>
-          <a:bodyPr wrap="square" rtlCol="0">
-            <a:spAutoFit/>
-          </a:bodyPr>
-          <a:lstStyle/>
-          <a:p>
-            <a:pPr algn="just"/>
-            <a:r>
-              <a:rPr lang="es-CL" sz="2000" dirty="0"/>
-              <a:t>Desde una visión mas de programador se busca:</a:t>
-            </a:r>
-          </a:p>
-          <a:p>
-            <a:pPr marL="285750" indent="-285750" algn="just">
-              <a:buFont typeface="Arial" panose="020B0604020202020204" pitchFamily="34" charset="0"/>
-              <a:buChar char="•"/>
-            </a:pPr>
-            <a:r>
-              <a:rPr lang="es-CL" sz="2000" dirty="0"/>
-              <a:t>Diseñar una arquitectura y base de datos acorde a lo que se busca</a:t>
-            </a:r>
-          </a:p>
-          <a:p>
-            <a:pPr marL="285750" indent="-285750" algn="just">
-              <a:buFont typeface="Arial" panose="020B0604020202020204" pitchFamily="34" charset="0"/>
-              <a:buChar char="•"/>
-            </a:pPr>
-            <a:r>
-              <a:rPr lang="es-CL" sz="2000" dirty="0"/>
-              <a:t>Implementar autenticación de 3 roles (cliente, trabajador y administrador)</a:t>
-            </a:r>
-          </a:p>
-          <a:p>
-            <a:pPr marL="285750" indent="-285750" algn="just">
-              <a:buFont typeface="Arial" panose="020B0604020202020204" pitchFamily="34" charset="0"/>
-              <a:buChar char="•"/>
-            </a:pPr>
-            <a:r>
-              <a:rPr lang="es-CL" sz="2000" dirty="0"/>
-              <a:t>Desarrollar perfiles públicos para trabajadores</a:t>
-            </a:r>
-          </a:p>
-          <a:p>
-            <a:pPr marL="285750" indent="-285750" algn="just">
-              <a:buFont typeface="Arial" panose="020B0604020202020204" pitchFamily="34" charset="0"/>
-              <a:buChar char="•"/>
-            </a:pPr>
-            <a:r>
-              <a:rPr lang="es-CL" sz="2000" dirty="0"/>
-              <a:t>Implementar un sistema de búsqueda y reservar de servicios</a:t>
-            </a:r>
-          </a:p>
-          <a:p>
-            <a:pPr marL="285750" indent="-285750" algn="just">
-              <a:buFont typeface="Arial" panose="020B0604020202020204" pitchFamily="34" charset="0"/>
-              <a:buChar char="•"/>
-            </a:pPr>
-            <a:r>
-              <a:rPr lang="es-CL" sz="2000" dirty="0"/>
-              <a:t>Crear un panel administrativo para gestionar usuarios y categorías</a:t>
-            </a:r>
-          </a:p>
-          <a:p>
-            <a:endParaRPr lang="es-CL" dirty="0"/>
-          </a:p>
-        </p:txBody>
-      </p:sp>
-    </p:spTree>
-    <p:extLst>
-      <p:ext uri="{BB962C8B-B14F-4D97-AF65-F5344CB8AC3E}">
-        <p14:creationId xmlns:p14="http://schemas.microsoft.com/office/powerpoint/2010/main" val="2313575771"/>
-      </p:ext>
-    </p:extLst>
-  </p:cSld>
-  <p:clrMapOvr>
-    <a:masterClrMapping/>
-  </p:clrMapOvr>
-</p:sld>
-</file>
-
-<file path=ppt/slides/slide7.xml><?xml version="1.0" encoding="utf-8"?>
-<p:sld xmlns:a="http://schemas.openxmlformats.org/drawingml/2006/main" xmlns:r="http://schemas.openxmlformats.org/officeDocument/2006/relationships" xmlns:p="http://schemas.openxmlformats.org/presentationml/2006/main">
-  <p:cSld>
-    <p:spTree>
-      <p:nvGrpSpPr>
-        <p:cNvPr id="1" name="">
-          <a:extLst>
-            <a:ext uri="{FF2B5EF4-FFF2-40B4-BE49-F238E27FC236}">
-              <a16:creationId xmlns:a16="http://schemas.microsoft.com/office/drawing/2014/main" id="{A7120D08-FAA9-04C5-67FC-34CD6EC0AC80}"/>
-            </a:ext>
-          </a:extLst>
-        </p:cNvPr>
-        <p:cNvGrpSpPr/>
-        <p:nvPr/>
-      </p:nvGrpSpPr>
-      <p:grpSpPr>
-        <a:xfrm>
-          <a:off x="0" y="0"/>
-          <a:ext cx="0" cy="0"/>
-          <a:chOff x="0" y="0"/>
-          <a:chExt cx="0" cy="0"/>
-        </a:xfrm>
-      </p:grpSpPr>
-      <p:sp>
-        <p:nvSpPr>
-          <p:cNvPr id="2" name="Title 1">
-            <a:extLst>
-              <a:ext uri="{FF2B5EF4-FFF2-40B4-BE49-F238E27FC236}">
-                <a16:creationId xmlns:a16="http://schemas.microsoft.com/office/drawing/2014/main" id="{3CC82FCD-8D66-3B32-F9A7-4AB2045E2003}"/>
-              </a:ext>
-            </a:extLst>
-          </p:cNvPr>
-          <p:cNvSpPr>
-            <a:spLocks noGrp="1"/>
-          </p:cNvSpPr>
-          <p:nvPr>
-            <p:ph type="title"/>
-          </p:nvPr>
-        </p:nvSpPr>
-        <p:spPr>
-          <a:xfrm>
-            <a:off x="1011608" y="0"/>
-            <a:ext cx="7958331" cy="1077229"/>
-          </a:xfrm>
-        </p:spPr>
-        <p:txBody>
-          <a:bodyPr/>
-          <a:lstStyle/>
-          <a:p>
-            <a:pPr algn="l"/>
-            <a:r>
-              <a:rPr lang="es-CL" dirty="0"/>
-              <a:t>Herramientas</a:t>
-            </a:r>
-          </a:p>
-        </p:txBody>
-      </p:sp>
-      <p:sp>
-        <p:nvSpPr>
-          <p:cNvPr id="3" name="Content Placeholder 2">
-            <a:extLst>
-              <a:ext uri="{FF2B5EF4-FFF2-40B4-BE49-F238E27FC236}">
-                <a16:creationId xmlns:a16="http://schemas.microsoft.com/office/drawing/2014/main" id="{A89DBC97-F5B2-59E3-A14D-0A0AF6968006}"/>
-              </a:ext>
-            </a:extLst>
-          </p:cNvPr>
-          <p:cNvSpPr>
-            <a:spLocks noGrp="1"/>
-          </p:cNvSpPr>
-          <p:nvPr>
-            <p:ph idx="1"/>
-          </p:nvPr>
-        </p:nvSpPr>
-        <p:spPr>
-          <a:xfrm>
-            <a:off x="1078992" y="720613"/>
-            <a:ext cx="5361759" cy="3485627"/>
-          </a:xfrm>
-        </p:spPr>
-        <p:txBody>
-          <a:bodyPr>
-            <a:normAutofit/>
-          </a:bodyPr>
-          <a:lstStyle/>
-          <a:p>
-            <a:r>
-              <a:rPr lang="es-CL" dirty="0" err="1"/>
-              <a:t>React</a:t>
-            </a:r>
-            <a:r>
-              <a:rPr lang="es-CL" dirty="0"/>
-              <a:t> - </a:t>
-            </a:r>
-            <a:r>
-              <a:rPr lang="es-CL" dirty="0" err="1"/>
-              <a:t>frontend</a:t>
-            </a:r>
-            <a:endParaRPr lang="es-CL" dirty="0"/>
-          </a:p>
-          <a:p>
-            <a:r>
-              <a:rPr lang="es-CL" dirty="0" err="1"/>
-              <a:t>FastApi</a:t>
-            </a:r>
-            <a:r>
-              <a:rPr lang="es-CL" dirty="0"/>
-              <a:t> – </a:t>
-            </a:r>
-            <a:r>
-              <a:rPr lang="es-CL" dirty="0" err="1"/>
-              <a:t>backed</a:t>
-            </a:r>
-            <a:r>
-              <a:rPr lang="es-CL" dirty="0"/>
-              <a:t> y api</a:t>
-            </a:r>
-          </a:p>
-          <a:p>
-            <a:r>
-              <a:rPr lang="es-CL" dirty="0"/>
-              <a:t>PostgreSQL – Base de datos</a:t>
-            </a:r>
-          </a:p>
-          <a:p>
-            <a:r>
-              <a:rPr lang="es-CL" dirty="0"/>
-              <a:t>Git + </a:t>
-            </a:r>
-            <a:r>
-              <a:rPr lang="es-CL" dirty="0" err="1"/>
-              <a:t>github</a:t>
-            </a:r>
-            <a:r>
-              <a:rPr lang="es-CL" dirty="0"/>
-              <a:t> – control de versiones</a:t>
-            </a:r>
-          </a:p>
-          <a:p>
-            <a:r>
-              <a:rPr lang="es-CL" dirty="0" err="1"/>
-              <a:t>Figma</a:t>
-            </a:r>
-            <a:r>
-              <a:rPr lang="es-CL" dirty="0"/>
-              <a:t> – prototipado temprano</a:t>
-            </a:r>
-          </a:p>
-          <a:p>
-            <a:endParaRPr lang="es-CL" dirty="0"/>
-          </a:p>
-        </p:txBody>
-      </p:sp>
-      <p:sp>
-        <p:nvSpPr>
-          <p:cNvPr id="5" name="TextBox 4">
-            <a:extLst>
-              <a:ext uri="{FF2B5EF4-FFF2-40B4-BE49-F238E27FC236}">
-                <a16:creationId xmlns:a16="http://schemas.microsoft.com/office/drawing/2014/main" id="{760B4DC7-7775-AB89-D04B-2C5A91F22CC5}"/>
-              </a:ext>
-            </a:extLst>
-          </p:cNvPr>
-          <p:cNvSpPr txBox="1"/>
-          <p:nvPr/>
-        </p:nvSpPr>
-        <p:spPr>
-          <a:xfrm>
-            <a:off x="1207008" y="3749040"/>
-            <a:ext cx="9052560" cy="1200329"/>
-          </a:xfrm>
-          <a:prstGeom prst="rect">
-            <a:avLst/>
-          </a:prstGeom>
-          <a:noFill/>
-        </p:spPr>
-        <p:txBody>
-          <a:bodyPr wrap="square" rtlCol="0">
-            <a:spAutoFit/>
-          </a:bodyPr>
-          <a:lstStyle/>
-          <a:p>
-            <a:r>
-              <a:rPr lang="es-CL" dirty="0"/>
-              <a:t>Esto se trabajara en metodología scrum dentro del plazo establecido de 10 a 12 semanas pasando por:</a:t>
-            </a:r>
-          </a:p>
-          <a:p>
-            <a:endParaRPr lang="es-CL" dirty="0"/>
-          </a:p>
-          <a:p>
-            <a:r>
-              <a:rPr lang="es-CL" dirty="0"/>
-              <a:t>Análisis del problema &gt; Diseño </a:t>
-            </a:r>
-            <a:r>
-              <a:rPr lang="en-US" dirty="0"/>
-              <a:t>&gt; Desarrollo &gt; Integration &gt; Pruebas &gt; Entrega</a:t>
-            </a:r>
-            <a:endParaRPr lang="es-CL" dirty="0"/>
-          </a:p>
-        </p:txBody>
-      </p:sp>
-      <p:pic>
-        <p:nvPicPr>
-          <p:cNvPr id="6" name="Picture 5" descr="Base de datos - Iconos gratis de tecnología">
-            <a:extLst>
-              <a:ext uri="{FF2B5EF4-FFF2-40B4-BE49-F238E27FC236}">
-                <a16:creationId xmlns:a16="http://schemas.microsoft.com/office/drawing/2014/main" id="{4D446C19-75F9-B74D-61DB-78AA3DC7BAAC}"/>
-              </a:ext>
-            </a:extLst>
-          </p:cNvPr>
-          <p:cNvPicPr>
-            <a:picLocks noChangeAspect="1"/>
-          </p:cNvPicPr>
-          <p:nvPr/>
-        </p:nvPicPr>
-        <p:blipFill>
-          <a:blip r:embed="rId2"/>
-          <a:stretch>
-            <a:fillRect/>
-          </a:stretch>
-        </p:blipFill>
-        <p:spPr>
-          <a:xfrm>
-            <a:off x="8852763" y="5086482"/>
-            <a:ext cx="1707463" cy="1707463"/>
-          </a:xfrm>
-          <a:prstGeom prst="rect">
-            <a:avLst/>
-          </a:prstGeom>
-        </p:spPr>
-      </p:pic>
-      <p:pic>
-        <p:nvPicPr>
-          <p:cNvPr id="7" name="Picture 6" descr="File:React-icon.svg - Wikimedia Commons">
-            <a:extLst>
-              <a:ext uri="{FF2B5EF4-FFF2-40B4-BE49-F238E27FC236}">
-                <a16:creationId xmlns:a16="http://schemas.microsoft.com/office/drawing/2014/main" id="{4E125975-80DA-AC69-8D35-92CBC46271DD}"/>
-              </a:ext>
-            </a:extLst>
-          </p:cNvPr>
-          <p:cNvPicPr>
-            <a:picLocks noChangeAspect="1"/>
-          </p:cNvPicPr>
-          <p:nvPr/>
-        </p:nvPicPr>
-        <p:blipFill>
-          <a:blip r:embed="rId3"/>
-          <a:stretch>
-            <a:fillRect/>
-          </a:stretch>
-        </p:blipFill>
-        <p:spPr>
-          <a:xfrm>
-            <a:off x="1203959" y="5126311"/>
-            <a:ext cx="1829319" cy="1627808"/>
-          </a:xfrm>
-          <a:prstGeom prst="rect">
-            <a:avLst/>
-          </a:prstGeom>
-        </p:spPr>
-      </p:pic>
-      <p:pic>
-        <p:nvPicPr>
-          <p:cNvPr id="9" name="Picture 8" descr="Fastapi Icon icon - Free Download PNG &amp; SVG | Streamline">
-            <a:extLst>
-              <a:ext uri="{FF2B5EF4-FFF2-40B4-BE49-F238E27FC236}">
-                <a16:creationId xmlns:a16="http://schemas.microsoft.com/office/drawing/2014/main" id="{93558AD7-580F-AFD0-4236-DA8A08285769}"/>
-              </a:ext>
-            </a:extLst>
-          </p:cNvPr>
-          <p:cNvPicPr>
-            <a:picLocks noChangeAspect="1"/>
-          </p:cNvPicPr>
-          <p:nvPr/>
-        </p:nvPicPr>
-        <p:blipFill>
-          <a:blip r:embed="rId4"/>
-          <a:stretch>
-            <a:fillRect/>
-          </a:stretch>
-        </p:blipFill>
-        <p:spPr>
-          <a:xfrm>
-            <a:off x="5327859" y="5172074"/>
-            <a:ext cx="1536281" cy="1536281"/>
-          </a:xfrm>
-          <a:prstGeom prst="rect">
-            <a:avLst/>
-          </a:prstGeom>
-        </p:spPr>
-      </p:pic>
-      <p:pic>
-        <p:nvPicPr>
-          <p:cNvPr id="10" name="Picture 9" descr="File:Postgresql elephant.svg - Wikimedia Commons">
-            <a:extLst>
-              <a:ext uri="{FF2B5EF4-FFF2-40B4-BE49-F238E27FC236}">
-                <a16:creationId xmlns:a16="http://schemas.microsoft.com/office/drawing/2014/main" id="{008CF901-65EA-2E3F-5678-9F31E5AFB273}"/>
-              </a:ext>
-            </a:extLst>
-          </p:cNvPr>
-          <p:cNvPicPr>
-            <a:picLocks noChangeAspect="1"/>
-          </p:cNvPicPr>
-          <p:nvPr/>
-        </p:nvPicPr>
-        <p:blipFill>
-          <a:blip r:embed="rId5"/>
-          <a:stretch>
-            <a:fillRect/>
-          </a:stretch>
-        </p:blipFill>
-        <p:spPr>
-          <a:xfrm>
-            <a:off x="9504724" y="4809744"/>
-            <a:ext cx="1509688" cy="1557998"/>
-          </a:xfrm>
-          <a:prstGeom prst="rect">
-            <a:avLst/>
-          </a:prstGeom>
-        </p:spPr>
-      </p:pic>
-    </p:spTree>
-    <p:extLst>
-      <p:ext uri="{BB962C8B-B14F-4D97-AF65-F5344CB8AC3E}">
-        <p14:creationId xmlns:p14="http://schemas.microsoft.com/office/powerpoint/2010/main" val="828875068"/>
-      </p:ext>
-    </p:extLst>
-  </p:cSld>
-  <p:clrMapOvr>
-    <a:masterClrMapping/>
-  </p:clrMapOvr>
-</p:sld>
-</file>
-
-<file path=ppt/slides/slide8.xml><?xml version="1.0" encoding="utf-8"?>
 <p:sld xmlns:a="http://schemas.openxmlformats.org/drawingml/2006/main" xmlns:r="http://schemas.openxmlformats.org/officeDocument/2006/relationships" xmlns:p="http://schemas.openxmlformats.org/presentationml/2006/main">
   <p:cSld>
     <p:spTree>
@@ -7359,7 +5141,7 @@
             <a:pPr algn="l"/>
             <a:r>
               <a:rPr lang="es-CL" dirty="0"/>
-              <a:t>Avances</a:t>
+              <a:t>Índice</a:t>
             </a:r>
           </a:p>
         </p:txBody>
@@ -7388,109 +5170,201 @@
         </p:spPr>
         <p:txBody>
           <a:bodyPr>
-            <a:normAutofit fontScale="70000" lnSpcReduction="20000"/>
+            <a:normAutofit/>
           </a:bodyPr>
           <a:lstStyle/>
           <a:p>
             <a:r>
               <a:rPr lang="es-CL" dirty="0"/>
-              <a:t>Se hicieron distintos avances en relación a lo que se esperaba aunque aun se esta bastante atrás del producto final que se requiere  como por ejemplo:</a:t>
-            </a:r>
-          </a:p>
-          <a:p>
-            <a:pPr marL="0" indent="0">
-              <a:buNone/>
-            </a:pPr>
+              <a:t>Arquitectura</a:t>
+            </a:r>
+          </a:p>
+          <a:p>
             <a:r>
               <a:rPr lang="es-CL" dirty="0"/>
-              <a:t>- Base de datos funcional con diferentes tipos de usuarios y diferentes tipos de oficios</a:t>
-            </a:r>
-          </a:p>
-          <a:p>
-            <a:pPr>
-              <a:buFontTx/>
-              <a:buChar char="-"/>
-            </a:pPr>
+              <a:t>Diseño BDD</a:t>
+            </a:r>
+          </a:p>
+          <a:p>
+            <a:r>
+              <a:rPr lang="es-CL" dirty="0" err="1"/>
+              <a:t>Backend</a:t>
+            </a:r>
+            <a:endParaRPr lang="es-CL" dirty="0"/>
+          </a:p>
+          <a:p>
+            <a:r>
+              <a:rPr lang="es-CL" dirty="0" err="1"/>
+              <a:t>FrontEnd</a:t>
+            </a:r>
+            <a:endParaRPr lang="es-CL" dirty="0"/>
+          </a:p>
+          <a:p>
             <a:r>
               <a:rPr lang="es-CL" dirty="0"/>
-              <a:t>Desarrollo del </a:t>
-            </a:r>
+              <a:t>Evidencias</a:t>
+            </a:r>
+          </a:p>
+          <a:p>
+            <a:r>
+              <a:rPr lang="es-CL" dirty="0"/>
+              <a:t>Conclusión </a:t>
+            </a:r>
+          </a:p>
+        </p:txBody>
+      </p:sp>
+    </p:spTree>
+    <p:extLst>
+      <p:ext uri="{BB962C8B-B14F-4D97-AF65-F5344CB8AC3E}">
+        <p14:creationId xmlns:p14="http://schemas.microsoft.com/office/powerpoint/2010/main" val="2437827173"/>
+      </p:ext>
+    </p:extLst>
+  </p:cSld>
+  <p:clrMapOvr>
+    <a:masterClrMapping/>
+  </p:clrMapOvr>
+</p:sld>
+</file>
+
+<file path=ppt/slides/slide3.xml><?xml version="1.0" encoding="utf-8"?>
+<p:sld xmlns:a="http://schemas.openxmlformats.org/drawingml/2006/main" xmlns:r="http://schemas.openxmlformats.org/officeDocument/2006/relationships" xmlns:p="http://schemas.openxmlformats.org/presentationml/2006/main">
+  <p:cSld>
+    <p:spTree>
+      <p:nvGrpSpPr>
+        <p:cNvPr id="1" name="">
+          <a:extLst>
+            <a:ext uri="{FF2B5EF4-FFF2-40B4-BE49-F238E27FC236}">
+              <a16:creationId xmlns:a16="http://schemas.microsoft.com/office/drawing/2014/main" id="{FE6D5568-E494-E49A-0376-97C0054C9E21}"/>
+            </a:ext>
+          </a:extLst>
+        </p:cNvPr>
+        <p:cNvGrpSpPr/>
+        <p:nvPr/>
+      </p:nvGrpSpPr>
+      <p:grpSpPr>
+        <a:xfrm>
+          <a:off x="0" y="0"/>
+          <a:ext cx="0" cy="0"/>
+          <a:chOff x="0" y="0"/>
+          <a:chExt cx="0" cy="0"/>
+        </a:xfrm>
+      </p:grpSpPr>
+      <p:sp>
+        <p:nvSpPr>
+          <p:cNvPr id="2" name="Title 1">
+            <a:extLst>
+              <a:ext uri="{FF2B5EF4-FFF2-40B4-BE49-F238E27FC236}">
+                <a16:creationId xmlns:a16="http://schemas.microsoft.com/office/drawing/2014/main" id="{F0A414ED-167A-3837-8BB6-1B4A86244805}"/>
+              </a:ext>
+            </a:extLst>
+          </p:cNvPr>
+          <p:cNvSpPr>
+            <a:spLocks noGrp="1"/>
+          </p:cNvSpPr>
+          <p:nvPr>
+            <p:ph type="title"/>
+          </p:nvPr>
+        </p:nvSpPr>
+        <p:spPr>
+          <a:xfrm>
+            <a:off x="1011608" y="0"/>
+            <a:ext cx="7958331" cy="1077229"/>
+          </a:xfrm>
+        </p:spPr>
+        <p:txBody>
+          <a:bodyPr/>
+          <a:lstStyle/>
+          <a:p>
+            <a:pPr algn="l"/>
+            <a:r>
+              <a:rPr lang="es-CL" dirty="0"/>
+              <a:t>Arquitectura</a:t>
+            </a:r>
+          </a:p>
+        </p:txBody>
+      </p:sp>
+      <p:sp>
+        <p:nvSpPr>
+          <p:cNvPr id="3" name="Content Placeholder 2">
+            <a:extLst>
+              <a:ext uri="{FF2B5EF4-FFF2-40B4-BE49-F238E27FC236}">
+                <a16:creationId xmlns:a16="http://schemas.microsoft.com/office/drawing/2014/main" id="{4D38E5B0-E44E-4137-D24D-7AA1ED12D0C4}"/>
+              </a:ext>
+            </a:extLst>
+          </p:cNvPr>
+          <p:cNvSpPr>
+            <a:spLocks noGrp="1"/>
+          </p:cNvSpPr>
+          <p:nvPr>
+            <p:ph idx="1"/>
+          </p:nvPr>
+        </p:nvSpPr>
+        <p:spPr>
+          <a:xfrm>
+            <a:off x="1011608" y="536851"/>
+            <a:ext cx="9513136" cy="3686795"/>
+          </a:xfrm>
+        </p:spPr>
+        <p:txBody>
+          <a:bodyPr>
+            <a:normAutofit/>
+          </a:bodyPr>
+          <a:lstStyle/>
+          <a:p>
             <a:r>
               <a:rPr lang="es-CL" dirty="0" err="1"/>
-              <a:t>backend</a:t>
+              <a:t>Frontend</a:t>
             </a:r>
             <a:r>
               <a:rPr lang="es-CL" dirty="0"/>
-              <a:t> funcional</a:t>
-            </a:r>
-          </a:p>
-          <a:p>
-            <a:pPr>
-              <a:buFontTx/>
-              <a:buChar char="-"/>
-            </a:pPr>
+              <a:t>: </a:t>
+            </a:r>
+            <a:r>
+              <a:rPr lang="es-CL" dirty="0" err="1"/>
+              <a:t>React</a:t>
+            </a:r>
             <a:r>
               <a:rPr lang="es-CL" dirty="0"/>
-              <a:t>Desarrollo del </a:t>
-            </a:r>
+              <a:t> + Vite</a:t>
+            </a:r>
+          </a:p>
+          <a:p>
             <a:r>
               <a:rPr lang="es-CL" dirty="0" err="1"/>
-              <a:t>front-end</a:t>
+              <a:t>Backend</a:t>
+            </a:r>
+            <a:r>
+              <a:rPr lang="es-CL" dirty="0"/>
+              <a:t>: Python + </a:t>
+            </a:r>
+            <a:r>
+              <a:rPr lang="es-CL" dirty="0" err="1"/>
+              <a:t>FastAPI</a:t>
             </a:r>
             <a:endParaRPr lang="es-CL" dirty="0"/>
           </a:p>
           <a:p>
-            <a:pPr>
-              <a:buFontTx/>
-              <a:buChar char="-"/>
-            </a:pPr>
+            <a:r>
+              <a:rPr lang="es-CL" dirty="0"/>
+              <a:t>Acceso a datos: </a:t>
+            </a:r>
             <a:r>
               <a:rPr lang="es-CL" dirty="0" err="1"/>
-              <a:t>Validacion</a:t>
-            </a:r>
+              <a:t>SQLAlchemy</a:t>
+            </a:r>
+            <a:endParaRPr lang="es-CL" dirty="0"/>
+          </a:p>
+          <a:p>
             <a:r>
               <a:rPr lang="es-CL" dirty="0"/>
-              <a:t> de usuario</a:t>
-            </a:r>
-          </a:p>
-          <a:p>
-            <a:pPr>
-              <a:buFontTx/>
-              <a:buChar char="-"/>
-            </a:pPr>
-            <a:r>
-              <a:rPr lang="es-CL" dirty="0" err="1"/>
-              <a:t>Redireccion</a:t>
-            </a:r>
-            <a:r>
-              <a:rPr lang="es-CL" dirty="0"/>
-              <a:t> según tipo de usuario</a:t>
-            </a:r>
-          </a:p>
-          <a:p>
-            <a:pPr>
-              <a:buFontTx/>
-              <a:buChar char="-"/>
-            </a:pPr>
-            <a:r>
-              <a:rPr lang="es-CL" dirty="0"/>
-              <a:t>Vista </a:t>
-            </a:r>
-            <a:r>
-              <a:rPr lang="es-CL" dirty="0" err="1"/>
-              <a:t>admin</a:t>
-            </a:r>
+              <a:t>Base de datos: PostgreSQL</a:t>
+            </a:r>
+          </a:p>
+          <a:p>
             <a:endParaRPr lang="es-CL" dirty="0"/>
           </a:p>
           <a:p>
-            <a:pPr>
-              <a:buFontTx/>
-              <a:buChar char="-"/>
-            </a:pPr>
-            <a:r>
-              <a:rPr lang="es-CL" dirty="0"/>
-              <a:t>Portafolio funcional</a:t>
-            </a:r>
+            <a:endParaRPr lang="es-CL" dirty="0"/>
           </a:p>
         </p:txBody>
       </p:sp>
@@ -7499,7 +5373,7 @@
           <p:cNvPr id="4" name="TextBox 3">
             <a:extLst>
               <a:ext uri="{FF2B5EF4-FFF2-40B4-BE49-F238E27FC236}">
-                <a16:creationId xmlns:a16="http://schemas.microsoft.com/office/drawing/2014/main" id="{398E85CC-85FC-5145-8179-6D375D6ECA43}"/>
+                <a16:creationId xmlns:a16="http://schemas.microsoft.com/office/drawing/2014/main" id="{AD699E86-466B-DC93-4886-4DB0C09618FF}"/>
               </a:ext>
             </a:extLst>
           </p:cNvPr>
@@ -7523,24 +5397,1320 @@
           <a:lstStyle/>
           <a:p>
             <a:r>
+              <a:rPr lang="es-CL" dirty="0" err="1"/>
+              <a:t>React</a:t>
+            </a:r>
+            <a:r>
               <a:rPr lang="es-CL" dirty="0"/>
-              <a:t>En base a lo que se busca con este proyecto aun se esta atrás en los distintos en temas como contacto de usuario, mantención activa de sesión, búsqueda de usuario por oficio, etc. </a:t>
+              <a:t> muestra la interfaz del proyecto, </a:t>
             </a:r>
             <a:r>
               <a:rPr lang="es-CL" dirty="0" err="1"/>
-              <a:t>Ademas</a:t>
+              <a:t>FastAPi</a:t>
             </a:r>
             <a:r>
               <a:rPr lang="es-CL" dirty="0"/>
-              <a:t> de re ajustar partes del proyecto.</a:t>
-            </a:r>
-          </a:p>
-        </p:txBody>
-      </p:sp>
+              <a:t> procesa las solicitudes para las conexiones y </a:t>
+            </a:r>
+            <a:r>
+              <a:rPr lang="es-CL" dirty="0" err="1"/>
+              <a:t>SQLAlchemy</a:t>
+            </a:r>
+            <a:r>
+              <a:rPr lang="es-CL" dirty="0"/>
+              <a:t> conecta el </a:t>
+            </a:r>
+            <a:r>
+              <a:rPr lang="es-CL" dirty="0" err="1"/>
+              <a:t>backend</a:t>
+            </a:r>
+            <a:r>
+              <a:rPr lang="es-CL" dirty="0"/>
+              <a:t> con la </a:t>
+            </a:r>
+            <a:r>
+              <a:rPr lang="es-CL" dirty="0" err="1"/>
+              <a:t>bdd</a:t>
+            </a:r>
+            <a:r>
+              <a:rPr lang="es-CL" dirty="0"/>
+              <a:t> de PostgreSQL, donde se almacenan los datos de los usuarios.</a:t>
+            </a:r>
+          </a:p>
+        </p:txBody>
+      </p:sp>
+      <p:pic>
+        <p:nvPicPr>
+          <p:cNvPr id="5" name="Picture 4" descr="Archivo:Pg logo.png - Wikipedia, la enciclopedia libre">
+            <a:extLst>
+              <a:ext uri="{FF2B5EF4-FFF2-40B4-BE49-F238E27FC236}">
+                <a16:creationId xmlns:a16="http://schemas.microsoft.com/office/drawing/2014/main" id="{55EE22F4-DC07-1556-D457-726CC9657826}"/>
+              </a:ext>
+            </a:extLst>
+          </p:cNvPr>
+          <p:cNvPicPr>
+            <a:picLocks noChangeAspect="1"/>
+          </p:cNvPicPr>
+          <p:nvPr/>
+        </p:nvPicPr>
+        <p:blipFill>
+          <a:blip r:embed="rId2"/>
+          <a:stretch>
+            <a:fillRect/>
+          </a:stretch>
+        </p:blipFill>
+        <p:spPr>
+          <a:xfrm>
+            <a:off x="9930955" y="110691"/>
+            <a:ext cx="1187577" cy="1225579"/>
+          </a:xfrm>
+          <a:prstGeom prst="rect">
+            <a:avLst/>
+          </a:prstGeom>
+        </p:spPr>
+      </p:pic>
+      <p:pic>
+        <p:nvPicPr>
+          <p:cNvPr id="6" name="Picture 5" descr="Archivo:Python-logo.png - Wikipedia, la enciclopedia libre">
+            <a:extLst>
+              <a:ext uri="{FF2B5EF4-FFF2-40B4-BE49-F238E27FC236}">
+                <a16:creationId xmlns:a16="http://schemas.microsoft.com/office/drawing/2014/main" id="{F8B2165A-2F00-1E33-F143-C519C47E2E7F}"/>
+              </a:ext>
+            </a:extLst>
+          </p:cNvPr>
+          <p:cNvPicPr>
+            <a:picLocks noChangeAspect="1"/>
+          </p:cNvPicPr>
+          <p:nvPr/>
+        </p:nvPicPr>
+        <p:blipFill>
+          <a:blip r:embed="rId3"/>
+          <a:stretch>
+            <a:fillRect/>
+          </a:stretch>
+        </p:blipFill>
+        <p:spPr>
+          <a:xfrm>
+            <a:off x="9509170" y="1066081"/>
+            <a:ext cx="1270973" cy="1392698"/>
+          </a:xfrm>
+          <a:prstGeom prst="rect">
+            <a:avLst/>
+          </a:prstGeom>
+        </p:spPr>
+      </p:pic>
+      <p:pic>
+        <p:nvPicPr>
+          <p:cNvPr id="8" name="Picture 7" descr="Fastapi Icon Icon | Free Download PNG &amp; SVG | SVG Logos">
+            <a:extLst>
+              <a:ext uri="{FF2B5EF4-FFF2-40B4-BE49-F238E27FC236}">
+                <a16:creationId xmlns:a16="http://schemas.microsoft.com/office/drawing/2014/main" id="{84CD6279-92AE-665F-413B-6EF9B937B6C2}"/>
+              </a:ext>
+            </a:extLst>
+          </p:cNvPr>
+          <p:cNvPicPr>
+            <a:picLocks noChangeAspect="1"/>
+          </p:cNvPicPr>
+          <p:nvPr/>
+        </p:nvPicPr>
+        <p:blipFill>
+          <a:blip r:embed="rId4"/>
+          <a:stretch>
+            <a:fillRect/>
+          </a:stretch>
+        </p:blipFill>
+        <p:spPr>
+          <a:xfrm>
+            <a:off x="7796956" y="1467961"/>
+            <a:ext cx="1712214" cy="1712214"/>
+          </a:xfrm>
+          <a:prstGeom prst="rect">
+            <a:avLst/>
+          </a:prstGeom>
+        </p:spPr>
+      </p:pic>
+      <p:pic>
+        <p:nvPicPr>
+          <p:cNvPr id="9" name="Picture 8" descr="File:React-icon.svg - Wikimedia Commons">
+            <a:extLst>
+              <a:ext uri="{FF2B5EF4-FFF2-40B4-BE49-F238E27FC236}">
+                <a16:creationId xmlns:a16="http://schemas.microsoft.com/office/drawing/2014/main" id="{73021FAF-5C22-7EB6-4AA3-3ABDBB96BCFD}"/>
+              </a:ext>
+            </a:extLst>
+          </p:cNvPr>
+          <p:cNvPicPr>
+            <a:picLocks noChangeAspect="1"/>
+          </p:cNvPicPr>
+          <p:nvPr/>
+        </p:nvPicPr>
+        <p:blipFill>
+          <a:blip r:embed="rId5"/>
+          <a:stretch>
+            <a:fillRect/>
+          </a:stretch>
+        </p:blipFill>
+        <p:spPr>
+          <a:xfrm>
+            <a:off x="8188073" y="101307"/>
+            <a:ext cx="1563731" cy="1392698"/>
+          </a:xfrm>
+          <a:prstGeom prst="rect">
+            <a:avLst/>
+          </a:prstGeom>
+        </p:spPr>
+      </p:pic>
     </p:spTree>
     <p:extLst>
       <p:ext uri="{BB962C8B-B14F-4D97-AF65-F5344CB8AC3E}">
-        <p14:creationId xmlns:p14="http://schemas.microsoft.com/office/powerpoint/2010/main" val="2437827173"/>
+        <p14:creationId xmlns:p14="http://schemas.microsoft.com/office/powerpoint/2010/main" val="3009934083"/>
+      </p:ext>
+    </p:extLst>
+  </p:cSld>
+  <p:clrMapOvr>
+    <a:masterClrMapping/>
+  </p:clrMapOvr>
+</p:sld>
+</file>
+
+<file path=ppt/slides/slide4.xml><?xml version="1.0" encoding="utf-8"?>
+<p:sld xmlns:a="http://schemas.openxmlformats.org/drawingml/2006/main" xmlns:r="http://schemas.openxmlformats.org/officeDocument/2006/relationships" xmlns:p="http://schemas.openxmlformats.org/presentationml/2006/main">
+  <p:cSld>
+    <p:spTree>
+      <p:nvGrpSpPr>
+        <p:cNvPr id="1" name="">
+          <a:extLst>
+            <a:ext uri="{FF2B5EF4-FFF2-40B4-BE49-F238E27FC236}">
+              <a16:creationId xmlns:a16="http://schemas.microsoft.com/office/drawing/2014/main" id="{EA7BAB27-B7A2-A308-AC53-C23E92D04FCB}"/>
+            </a:ext>
+          </a:extLst>
+        </p:cNvPr>
+        <p:cNvGrpSpPr/>
+        <p:nvPr/>
+      </p:nvGrpSpPr>
+      <p:grpSpPr>
+        <a:xfrm>
+          <a:off x="0" y="0"/>
+          <a:ext cx="0" cy="0"/>
+          <a:chOff x="0" y="0"/>
+          <a:chExt cx="0" cy="0"/>
+        </a:xfrm>
+      </p:grpSpPr>
+      <p:sp>
+        <p:nvSpPr>
+          <p:cNvPr id="2" name="Title 1">
+            <a:extLst>
+              <a:ext uri="{FF2B5EF4-FFF2-40B4-BE49-F238E27FC236}">
+                <a16:creationId xmlns:a16="http://schemas.microsoft.com/office/drawing/2014/main" id="{7078D339-E88D-4461-8E1F-0EF31B7DC053}"/>
+              </a:ext>
+            </a:extLst>
+          </p:cNvPr>
+          <p:cNvSpPr>
+            <a:spLocks noGrp="1"/>
+          </p:cNvSpPr>
+          <p:nvPr>
+            <p:ph type="title"/>
+          </p:nvPr>
+        </p:nvSpPr>
+        <p:spPr>
+          <a:xfrm>
+            <a:off x="1011608" y="0"/>
+            <a:ext cx="7958331" cy="1077229"/>
+          </a:xfrm>
+        </p:spPr>
+        <p:txBody>
+          <a:bodyPr/>
+          <a:lstStyle/>
+          <a:p>
+            <a:pPr algn="l"/>
+            <a:r>
+              <a:rPr lang="es-CL" dirty="0"/>
+              <a:t>Diseño BDD</a:t>
+            </a:r>
+            <a:br>
+              <a:rPr lang="es-CL" dirty="0"/>
+            </a:br>
+            <a:endParaRPr lang="es-CL" dirty="0"/>
+          </a:p>
+        </p:txBody>
+      </p:sp>
+      <p:sp>
+        <p:nvSpPr>
+          <p:cNvPr id="3" name="Content Placeholder 2">
+            <a:extLst>
+              <a:ext uri="{FF2B5EF4-FFF2-40B4-BE49-F238E27FC236}">
+                <a16:creationId xmlns:a16="http://schemas.microsoft.com/office/drawing/2014/main" id="{C5EF3B91-EE55-8171-EB0C-59F3584A7437}"/>
+              </a:ext>
+            </a:extLst>
+          </p:cNvPr>
+          <p:cNvSpPr>
+            <a:spLocks noGrp="1"/>
+          </p:cNvSpPr>
+          <p:nvPr>
+            <p:ph idx="1"/>
+          </p:nvPr>
+        </p:nvSpPr>
+        <p:spPr>
+          <a:xfrm>
+            <a:off x="1011608" y="536851"/>
+            <a:ext cx="9513136" cy="3686795"/>
+          </a:xfrm>
+        </p:spPr>
+        <p:txBody>
+          <a:bodyPr>
+            <a:normAutofit/>
+          </a:bodyPr>
+          <a:lstStyle/>
+          <a:p>
+            <a:r>
+              <a:rPr lang="es-CL" dirty="0"/>
+              <a:t>Motor: PostgreSQL</a:t>
+            </a:r>
+          </a:p>
+          <a:p>
+            <a:r>
+              <a:rPr lang="es-CL" dirty="0"/>
+              <a:t>ORM: </a:t>
+            </a:r>
+            <a:r>
+              <a:rPr lang="es-CL" dirty="0" err="1"/>
+              <a:t>SQLAlchemy</a:t>
+            </a:r>
+            <a:endParaRPr lang="es-CL" dirty="0"/>
+          </a:p>
+          <a:p>
+            <a:r>
+              <a:rPr lang="es-CL" dirty="0"/>
+              <a:t>Tablas principales: usuarios, trabajadores y </a:t>
+            </a:r>
+            <a:r>
+              <a:rPr lang="es-CL" dirty="0" err="1"/>
+              <a:t>categorias</a:t>
+            </a:r>
+            <a:endParaRPr lang="es-CL" dirty="0"/>
+          </a:p>
+          <a:p>
+            <a:r>
+              <a:rPr lang="es-CL" dirty="0"/>
+              <a:t>Relaciones: vinculan a los usuarios con sus perfiles profesionales y las categorías de sus oficios</a:t>
+            </a:r>
+          </a:p>
+          <a:p>
+            <a:endParaRPr lang="es-CL" dirty="0"/>
+          </a:p>
+        </p:txBody>
+      </p:sp>
+      <p:pic>
+        <p:nvPicPr>
+          <p:cNvPr id="5" name="Picture 4" descr="Archivo:Pg logo.png - Wikipedia, la enciclopedia libre">
+            <a:extLst>
+              <a:ext uri="{FF2B5EF4-FFF2-40B4-BE49-F238E27FC236}">
+                <a16:creationId xmlns:a16="http://schemas.microsoft.com/office/drawing/2014/main" id="{7D1950B7-D216-0474-C277-258C8920DE03}"/>
+              </a:ext>
+            </a:extLst>
+          </p:cNvPr>
+          <p:cNvPicPr>
+            <a:picLocks noChangeAspect="1"/>
+          </p:cNvPicPr>
+          <p:nvPr/>
+        </p:nvPicPr>
+        <p:blipFill>
+          <a:blip r:embed="rId2"/>
+          <a:stretch>
+            <a:fillRect/>
+          </a:stretch>
+        </p:blipFill>
+        <p:spPr>
+          <a:xfrm>
+            <a:off x="9930955" y="110691"/>
+            <a:ext cx="1187577" cy="1225579"/>
+          </a:xfrm>
+          <a:prstGeom prst="rect">
+            <a:avLst/>
+          </a:prstGeom>
+        </p:spPr>
+      </p:pic>
+      <p:pic>
+        <p:nvPicPr>
+          <p:cNvPr id="10" name="Picture 9">
+            <a:extLst>
+              <a:ext uri="{FF2B5EF4-FFF2-40B4-BE49-F238E27FC236}">
+                <a16:creationId xmlns:a16="http://schemas.microsoft.com/office/drawing/2014/main" id="{B677B1DB-4F77-0D54-2B0A-EB07F6F67928}"/>
+              </a:ext>
+            </a:extLst>
+          </p:cNvPr>
+          <p:cNvPicPr>
+            <a:picLocks noChangeAspect="1"/>
+          </p:cNvPicPr>
+          <p:nvPr/>
+        </p:nvPicPr>
+        <p:blipFill>
+          <a:blip r:embed="rId3"/>
+          <a:stretch>
+            <a:fillRect/>
+          </a:stretch>
+        </p:blipFill>
+        <p:spPr>
+          <a:xfrm>
+            <a:off x="6757416" y="3028810"/>
+            <a:ext cx="5434584" cy="3829190"/>
+          </a:xfrm>
+          <a:prstGeom prst="rect">
+            <a:avLst/>
+          </a:prstGeom>
+        </p:spPr>
+      </p:pic>
+      <p:sp>
+        <p:nvSpPr>
+          <p:cNvPr id="11" name="TextBox 10">
+            <a:extLst>
+              <a:ext uri="{FF2B5EF4-FFF2-40B4-BE49-F238E27FC236}">
+                <a16:creationId xmlns:a16="http://schemas.microsoft.com/office/drawing/2014/main" id="{B1657074-733F-AE9D-BB02-42215791ABFD}"/>
+              </a:ext>
+            </a:extLst>
+          </p:cNvPr>
+          <p:cNvSpPr txBox="1"/>
+          <p:nvPr/>
+        </p:nvSpPr>
+        <p:spPr>
+          <a:xfrm>
+            <a:off x="1011608" y="3712464"/>
+            <a:ext cx="5645224" cy="1477328"/>
+          </a:xfrm>
+          <a:prstGeom prst="rect">
+            <a:avLst/>
+          </a:prstGeom>
+          <a:noFill/>
+        </p:spPr>
+        <p:txBody>
+          <a:bodyPr wrap="square" rtlCol="0">
+            <a:spAutoFit/>
+          </a:bodyPr>
+          <a:lstStyle/>
+          <a:p>
+            <a:r>
+              <a:rPr lang="es-CL" dirty="0"/>
+              <a:t>Lo importante dentro </a:t>
+            </a:r>
+            <a:r>
+              <a:rPr lang="es-CL" dirty="0" err="1"/>
+              <a:t>dentro</a:t>
+            </a:r>
+            <a:r>
+              <a:rPr lang="es-CL" dirty="0"/>
+              <a:t> del modelo de base de datos es el uso de </a:t>
+            </a:r>
+            <a:r>
+              <a:rPr lang="es-CL" dirty="0" err="1"/>
+              <a:t>SQLAlchemy</a:t>
+            </a:r>
+            <a:r>
+              <a:rPr lang="es-CL" dirty="0"/>
+              <a:t> el cual permite que el </a:t>
+            </a:r>
+            <a:r>
+              <a:rPr lang="es-CL" dirty="0" err="1"/>
+              <a:t>backend</a:t>
+            </a:r>
+            <a:r>
+              <a:rPr lang="es-CL" dirty="0"/>
+              <a:t> y </a:t>
+            </a:r>
+            <a:r>
+              <a:rPr lang="es-CL" dirty="0" err="1"/>
+              <a:t>bdd</a:t>
+            </a:r>
+            <a:r>
+              <a:rPr lang="es-CL" dirty="0"/>
+              <a:t> logren una comunicación efectiva facilitando las consultas y modificación de datos mediante Python.</a:t>
+            </a:r>
+          </a:p>
+        </p:txBody>
+      </p:sp>
+    </p:spTree>
+    <p:extLst>
+      <p:ext uri="{BB962C8B-B14F-4D97-AF65-F5344CB8AC3E}">
+        <p14:creationId xmlns:p14="http://schemas.microsoft.com/office/powerpoint/2010/main" val="830208361"/>
+      </p:ext>
+    </p:extLst>
+  </p:cSld>
+  <p:clrMapOvr>
+    <a:masterClrMapping/>
+  </p:clrMapOvr>
+</p:sld>
+</file>
+
+<file path=ppt/slides/slide5.xml><?xml version="1.0" encoding="utf-8"?>
+<p:sld xmlns:a="http://schemas.openxmlformats.org/drawingml/2006/main" xmlns:r="http://schemas.openxmlformats.org/officeDocument/2006/relationships" xmlns:p="http://schemas.openxmlformats.org/presentationml/2006/main">
+  <p:cSld>
+    <p:spTree>
+      <p:nvGrpSpPr>
+        <p:cNvPr id="1" name="">
+          <a:extLst>
+            <a:ext uri="{FF2B5EF4-FFF2-40B4-BE49-F238E27FC236}">
+              <a16:creationId xmlns:a16="http://schemas.microsoft.com/office/drawing/2014/main" id="{AAA0A593-6022-35DD-D7DC-B249933C8E28}"/>
+            </a:ext>
+          </a:extLst>
+        </p:cNvPr>
+        <p:cNvGrpSpPr/>
+        <p:nvPr/>
+      </p:nvGrpSpPr>
+      <p:grpSpPr>
+        <a:xfrm>
+          <a:off x="0" y="0"/>
+          <a:ext cx="0" cy="0"/>
+          <a:chOff x="0" y="0"/>
+          <a:chExt cx="0" cy="0"/>
+        </a:xfrm>
+      </p:grpSpPr>
+      <p:sp>
+        <p:nvSpPr>
+          <p:cNvPr id="2" name="Title 1">
+            <a:extLst>
+              <a:ext uri="{FF2B5EF4-FFF2-40B4-BE49-F238E27FC236}">
+                <a16:creationId xmlns:a16="http://schemas.microsoft.com/office/drawing/2014/main" id="{12CF1AFD-EC81-AB4D-0C51-AFCCBB7E0C4B}"/>
+              </a:ext>
+            </a:extLst>
+          </p:cNvPr>
+          <p:cNvSpPr>
+            <a:spLocks noGrp="1"/>
+          </p:cNvSpPr>
+          <p:nvPr>
+            <p:ph type="title"/>
+          </p:nvPr>
+        </p:nvSpPr>
+        <p:spPr>
+          <a:xfrm>
+            <a:off x="1011608" y="0"/>
+            <a:ext cx="7958331" cy="1077229"/>
+          </a:xfrm>
+        </p:spPr>
+        <p:txBody>
+          <a:bodyPr/>
+          <a:lstStyle/>
+          <a:p>
+            <a:pPr algn="l"/>
+            <a:r>
+              <a:rPr lang="es-CL" dirty="0" err="1"/>
+              <a:t>Backend</a:t>
+            </a:r>
+            <a:br>
+              <a:rPr lang="es-CL" dirty="0"/>
+            </a:br>
+            <a:endParaRPr lang="es-CL" dirty="0"/>
+          </a:p>
+        </p:txBody>
+      </p:sp>
+      <p:sp>
+        <p:nvSpPr>
+          <p:cNvPr id="3" name="Content Placeholder 2">
+            <a:extLst>
+              <a:ext uri="{FF2B5EF4-FFF2-40B4-BE49-F238E27FC236}">
+                <a16:creationId xmlns:a16="http://schemas.microsoft.com/office/drawing/2014/main" id="{8F0CA228-FB96-C2CA-177F-D18995409EF3}"/>
+              </a:ext>
+            </a:extLst>
+          </p:cNvPr>
+          <p:cNvSpPr>
+            <a:spLocks noGrp="1"/>
+          </p:cNvSpPr>
+          <p:nvPr>
+            <p:ph idx="1"/>
+          </p:nvPr>
+        </p:nvSpPr>
+        <p:spPr>
+          <a:xfrm>
+            <a:off x="1011608" y="536851"/>
+            <a:ext cx="5855536" cy="2782421"/>
+          </a:xfrm>
+        </p:spPr>
+        <p:txBody>
+          <a:bodyPr>
+            <a:normAutofit/>
+          </a:bodyPr>
+          <a:lstStyle/>
+          <a:p>
+            <a:r>
+              <a:rPr lang="es-CL" dirty="0"/>
+              <a:t>Tecnologías: Python + </a:t>
+            </a:r>
+            <a:r>
+              <a:rPr lang="es-CL" dirty="0" err="1"/>
+              <a:t>FastAPI</a:t>
+            </a:r>
+            <a:endParaRPr lang="es-CL" dirty="0"/>
+          </a:p>
+          <a:p>
+            <a:r>
+              <a:rPr lang="es-CL" dirty="0"/>
+              <a:t>API REST: comunicación entre </a:t>
+            </a:r>
+            <a:r>
+              <a:rPr lang="es-CL" dirty="0" err="1"/>
+              <a:t>FrontEnd</a:t>
+            </a:r>
+            <a:r>
+              <a:rPr lang="es-CL" dirty="0"/>
+              <a:t> y BDD</a:t>
+            </a:r>
+          </a:p>
+          <a:p>
+            <a:r>
+              <a:rPr lang="es-CL" dirty="0"/>
+              <a:t>Swagger: documentación y pruebas de la funcionabilidad de la API</a:t>
+            </a:r>
+          </a:p>
+        </p:txBody>
+      </p:sp>
+      <p:pic>
+        <p:nvPicPr>
+          <p:cNvPr id="6" name="Picture 5" descr="Archivo:Python-logo.png - Wikipedia, la enciclopedia libre">
+            <a:extLst>
+              <a:ext uri="{FF2B5EF4-FFF2-40B4-BE49-F238E27FC236}">
+                <a16:creationId xmlns:a16="http://schemas.microsoft.com/office/drawing/2014/main" id="{C9A457C2-8604-8028-9A9C-E09198CF5F26}"/>
+              </a:ext>
+            </a:extLst>
+          </p:cNvPr>
+          <p:cNvPicPr>
+            <a:picLocks noChangeAspect="1"/>
+          </p:cNvPicPr>
+          <p:nvPr/>
+        </p:nvPicPr>
+        <p:blipFill>
+          <a:blip r:embed="rId2"/>
+          <a:stretch>
+            <a:fillRect/>
+          </a:stretch>
+        </p:blipFill>
+        <p:spPr>
+          <a:xfrm>
+            <a:off x="9936195" y="75263"/>
+            <a:ext cx="1270973" cy="1392698"/>
+          </a:xfrm>
+          <a:prstGeom prst="rect">
+            <a:avLst/>
+          </a:prstGeom>
+        </p:spPr>
+      </p:pic>
+      <p:pic>
+        <p:nvPicPr>
+          <p:cNvPr id="8" name="Picture 7" descr="Fastapi Icon Icon | Free Download PNG &amp; SVG | SVG Logos">
+            <a:extLst>
+              <a:ext uri="{FF2B5EF4-FFF2-40B4-BE49-F238E27FC236}">
+                <a16:creationId xmlns:a16="http://schemas.microsoft.com/office/drawing/2014/main" id="{0E0B813A-0CBA-E7FD-DA0B-CFC59F8BBD5E}"/>
+              </a:ext>
+            </a:extLst>
+          </p:cNvPr>
+          <p:cNvPicPr>
+            <a:picLocks noChangeAspect="1"/>
+          </p:cNvPicPr>
+          <p:nvPr/>
+        </p:nvPicPr>
+        <p:blipFill>
+          <a:blip r:embed="rId3"/>
+          <a:stretch>
+            <a:fillRect/>
+          </a:stretch>
+        </p:blipFill>
+        <p:spPr>
+          <a:xfrm>
+            <a:off x="9549493" y="919321"/>
+            <a:ext cx="1712214" cy="1712214"/>
+          </a:xfrm>
+          <a:prstGeom prst="rect">
+            <a:avLst/>
+          </a:prstGeom>
+        </p:spPr>
+      </p:pic>
+      <p:pic>
+        <p:nvPicPr>
+          <p:cNvPr id="10" name="Picture 9">
+            <a:extLst>
+              <a:ext uri="{FF2B5EF4-FFF2-40B4-BE49-F238E27FC236}">
+                <a16:creationId xmlns:a16="http://schemas.microsoft.com/office/drawing/2014/main" id="{66E33850-C8C7-303F-1A98-566ED1C5CB16}"/>
+              </a:ext>
+            </a:extLst>
+          </p:cNvPr>
+          <p:cNvPicPr>
+            <a:picLocks noChangeAspect="1"/>
+          </p:cNvPicPr>
+          <p:nvPr/>
+        </p:nvPicPr>
+        <p:blipFill>
+          <a:blip r:embed="rId4"/>
+          <a:stretch>
+            <a:fillRect/>
+          </a:stretch>
+        </p:blipFill>
+        <p:spPr>
+          <a:xfrm>
+            <a:off x="5406171" y="3966929"/>
+            <a:ext cx="5855536" cy="2782422"/>
+          </a:xfrm>
+          <a:prstGeom prst="rect">
+            <a:avLst/>
+          </a:prstGeom>
+        </p:spPr>
+      </p:pic>
+      <p:sp>
+        <p:nvSpPr>
+          <p:cNvPr id="11" name="TextBox 10">
+            <a:extLst>
+              <a:ext uri="{FF2B5EF4-FFF2-40B4-BE49-F238E27FC236}">
+                <a16:creationId xmlns:a16="http://schemas.microsoft.com/office/drawing/2014/main" id="{1A583EEC-707A-138C-055E-21190F8449A8}"/>
+              </a:ext>
+            </a:extLst>
+          </p:cNvPr>
+          <p:cNvSpPr txBox="1"/>
+          <p:nvPr/>
+        </p:nvSpPr>
+        <p:spPr>
+          <a:xfrm>
+            <a:off x="1106424" y="3017520"/>
+            <a:ext cx="5760720" cy="1200329"/>
+          </a:xfrm>
+          <a:prstGeom prst="rect">
+            <a:avLst/>
+          </a:prstGeom>
+          <a:noFill/>
+        </p:spPr>
+        <p:txBody>
+          <a:bodyPr wrap="square" rtlCol="0">
+            <a:spAutoFit/>
+          </a:bodyPr>
+          <a:lstStyle/>
+          <a:p>
+            <a:r>
+              <a:rPr lang="es-CL" dirty="0"/>
+              <a:t>El </a:t>
+            </a:r>
+            <a:r>
+              <a:rPr lang="es-CL" dirty="0" err="1"/>
+              <a:t>backend</a:t>
+            </a:r>
+            <a:r>
+              <a:rPr lang="es-CL" dirty="0"/>
+              <a:t> se desarrollo con </a:t>
+            </a:r>
+            <a:r>
+              <a:rPr lang="es-CL" dirty="0" err="1"/>
+              <a:t>FastAPI</a:t>
+            </a:r>
+            <a:r>
+              <a:rPr lang="es-CL" dirty="0"/>
+              <a:t> por su sencilles para procesar las solicitudes de las aplicación, gestionar usuarios y trabajadores, además de entregar los datos hacia el </a:t>
+            </a:r>
+            <a:r>
+              <a:rPr lang="es-CL" dirty="0" err="1"/>
+              <a:t>frontend</a:t>
+            </a:r>
+            <a:r>
+              <a:rPr lang="es-CL" dirty="0"/>
+              <a:t>.</a:t>
+            </a:r>
+          </a:p>
+        </p:txBody>
+      </p:sp>
+    </p:spTree>
+    <p:extLst>
+      <p:ext uri="{BB962C8B-B14F-4D97-AF65-F5344CB8AC3E}">
+        <p14:creationId xmlns:p14="http://schemas.microsoft.com/office/powerpoint/2010/main" val="3257197426"/>
+      </p:ext>
+    </p:extLst>
+  </p:cSld>
+  <p:clrMapOvr>
+    <a:masterClrMapping/>
+  </p:clrMapOvr>
+</p:sld>
+</file>
+
+<file path=ppt/slides/slide6.xml><?xml version="1.0" encoding="utf-8"?>
+<p:sld xmlns:a="http://schemas.openxmlformats.org/drawingml/2006/main" xmlns:r="http://schemas.openxmlformats.org/officeDocument/2006/relationships" xmlns:p="http://schemas.openxmlformats.org/presentationml/2006/main">
+  <p:cSld>
+    <p:spTree>
+      <p:nvGrpSpPr>
+        <p:cNvPr id="1" name="">
+          <a:extLst>
+            <a:ext uri="{FF2B5EF4-FFF2-40B4-BE49-F238E27FC236}">
+              <a16:creationId xmlns:a16="http://schemas.microsoft.com/office/drawing/2014/main" id="{049765D3-34D9-0A8B-0823-B85D845F7D08}"/>
+            </a:ext>
+          </a:extLst>
+        </p:cNvPr>
+        <p:cNvGrpSpPr/>
+        <p:nvPr/>
+      </p:nvGrpSpPr>
+      <p:grpSpPr>
+        <a:xfrm>
+          <a:off x="0" y="0"/>
+          <a:ext cx="0" cy="0"/>
+          <a:chOff x="0" y="0"/>
+          <a:chExt cx="0" cy="0"/>
+        </a:xfrm>
+      </p:grpSpPr>
+      <p:sp>
+        <p:nvSpPr>
+          <p:cNvPr id="2" name="Title 1">
+            <a:extLst>
+              <a:ext uri="{FF2B5EF4-FFF2-40B4-BE49-F238E27FC236}">
+                <a16:creationId xmlns:a16="http://schemas.microsoft.com/office/drawing/2014/main" id="{EE79E9CF-8C94-9385-B57C-B97B2AC8EFA2}"/>
+              </a:ext>
+            </a:extLst>
+          </p:cNvPr>
+          <p:cNvSpPr>
+            <a:spLocks noGrp="1"/>
+          </p:cNvSpPr>
+          <p:nvPr>
+            <p:ph type="title"/>
+          </p:nvPr>
+        </p:nvSpPr>
+        <p:spPr>
+          <a:xfrm>
+            <a:off x="1011608" y="0"/>
+            <a:ext cx="7958331" cy="1077229"/>
+          </a:xfrm>
+        </p:spPr>
+        <p:txBody>
+          <a:bodyPr/>
+          <a:lstStyle/>
+          <a:p>
+            <a:pPr algn="l"/>
+            <a:r>
+              <a:rPr lang="es-CL" dirty="0" err="1"/>
+              <a:t>FrontEnd</a:t>
+            </a:r>
+            <a:endParaRPr lang="es-CL" dirty="0"/>
+          </a:p>
+        </p:txBody>
+      </p:sp>
+      <p:pic>
+        <p:nvPicPr>
+          <p:cNvPr id="9" name="Picture 8" descr="File:React-icon.svg - Wikimedia Commons">
+            <a:extLst>
+              <a:ext uri="{FF2B5EF4-FFF2-40B4-BE49-F238E27FC236}">
+                <a16:creationId xmlns:a16="http://schemas.microsoft.com/office/drawing/2014/main" id="{555617D4-0B31-CFE8-9961-CF185BDFB747}"/>
+              </a:ext>
+            </a:extLst>
+          </p:cNvPr>
+          <p:cNvPicPr>
+            <a:picLocks noChangeAspect="1"/>
+          </p:cNvPicPr>
+          <p:nvPr/>
+        </p:nvPicPr>
+        <p:blipFill>
+          <a:blip r:embed="rId2"/>
+          <a:stretch>
+            <a:fillRect/>
+          </a:stretch>
+        </p:blipFill>
+        <p:spPr>
+          <a:xfrm>
+            <a:off x="9643437" y="110451"/>
+            <a:ext cx="1563731" cy="1392698"/>
+          </a:xfrm>
+          <a:prstGeom prst="rect">
+            <a:avLst/>
+          </a:prstGeom>
+        </p:spPr>
+      </p:pic>
+      <p:pic>
+        <p:nvPicPr>
+          <p:cNvPr id="10" name="Picture 9">
+            <a:extLst>
+              <a:ext uri="{FF2B5EF4-FFF2-40B4-BE49-F238E27FC236}">
+                <a16:creationId xmlns:a16="http://schemas.microsoft.com/office/drawing/2014/main" id="{ADE064D4-3CBC-22D5-F227-7FDAD1E13227}"/>
+              </a:ext>
+            </a:extLst>
+          </p:cNvPr>
+          <p:cNvPicPr>
+            <a:picLocks noChangeAspect="1"/>
+          </p:cNvPicPr>
+          <p:nvPr/>
+        </p:nvPicPr>
+        <p:blipFill>
+          <a:blip r:embed="rId3"/>
+          <a:stretch>
+            <a:fillRect/>
+          </a:stretch>
+        </p:blipFill>
+        <p:spPr>
+          <a:xfrm>
+            <a:off x="1146899" y="877993"/>
+            <a:ext cx="5806695" cy="2551007"/>
+          </a:xfrm>
+          <a:prstGeom prst="rect">
+            <a:avLst/>
+          </a:prstGeom>
+        </p:spPr>
+      </p:pic>
+      <p:pic>
+        <p:nvPicPr>
+          <p:cNvPr id="12" name="Picture 11">
+            <a:extLst>
+              <a:ext uri="{FF2B5EF4-FFF2-40B4-BE49-F238E27FC236}">
+                <a16:creationId xmlns:a16="http://schemas.microsoft.com/office/drawing/2014/main" id="{67FFCBE8-04FF-2AF8-FC17-8C538EE659CC}"/>
+              </a:ext>
+            </a:extLst>
+          </p:cNvPr>
+          <p:cNvPicPr>
+            <a:picLocks noChangeAspect="1"/>
+          </p:cNvPicPr>
+          <p:nvPr/>
+        </p:nvPicPr>
+        <p:blipFill>
+          <a:blip r:embed="rId4"/>
+          <a:stretch>
+            <a:fillRect/>
+          </a:stretch>
+        </p:blipFill>
+        <p:spPr>
+          <a:xfrm>
+            <a:off x="1146899" y="3596231"/>
+            <a:ext cx="7687748" cy="2953162"/>
+          </a:xfrm>
+          <a:prstGeom prst="rect">
+            <a:avLst/>
+          </a:prstGeom>
+        </p:spPr>
+      </p:pic>
+      <p:sp>
+        <p:nvSpPr>
+          <p:cNvPr id="15" name="TextBox 14">
+            <a:extLst>
+              <a:ext uri="{FF2B5EF4-FFF2-40B4-BE49-F238E27FC236}">
+                <a16:creationId xmlns:a16="http://schemas.microsoft.com/office/drawing/2014/main" id="{C1405A39-C678-32F7-0511-1D4E4F4D4608}"/>
+              </a:ext>
+            </a:extLst>
+          </p:cNvPr>
+          <p:cNvSpPr txBox="1"/>
+          <p:nvPr/>
+        </p:nvSpPr>
+        <p:spPr>
+          <a:xfrm>
+            <a:off x="7114032" y="1325880"/>
+            <a:ext cx="3346704" cy="369332"/>
+          </a:xfrm>
+          <a:prstGeom prst="rect">
+            <a:avLst/>
+          </a:prstGeom>
+          <a:noFill/>
+        </p:spPr>
+        <p:txBody>
+          <a:bodyPr wrap="square" rtlCol="0">
+            <a:spAutoFit/>
+          </a:bodyPr>
+          <a:lstStyle/>
+          <a:p>
+            <a:r>
+              <a:rPr lang="es-CL" dirty="0" err="1"/>
+              <a:t>React</a:t>
+            </a:r>
+            <a:r>
+              <a:rPr lang="es-CL" dirty="0"/>
+              <a:t> + Vite + CSS</a:t>
+            </a:r>
+          </a:p>
+        </p:txBody>
+      </p:sp>
+    </p:spTree>
+    <p:extLst>
+      <p:ext uri="{BB962C8B-B14F-4D97-AF65-F5344CB8AC3E}">
+        <p14:creationId xmlns:p14="http://schemas.microsoft.com/office/powerpoint/2010/main" val="3674139621"/>
+      </p:ext>
+    </p:extLst>
+  </p:cSld>
+  <p:clrMapOvr>
+    <a:masterClrMapping/>
+  </p:clrMapOvr>
+</p:sld>
+</file>
+
+<file path=ppt/slides/slide7.xml><?xml version="1.0" encoding="utf-8"?>
+<p:sld xmlns:a="http://schemas.openxmlformats.org/drawingml/2006/main" xmlns:r="http://schemas.openxmlformats.org/officeDocument/2006/relationships" xmlns:p="http://schemas.openxmlformats.org/presentationml/2006/main">
+  <p:cSld>
+    <p:spTree>
+      <p:nvGrpSpPr>
+        <p:cNvPr id="1" name="">
+          <a:extLst>
+            <a:ext uri="{FF2B5EF4-FFF2-40B4-BE49-F238E27FC236}">
+              <a16:creationId xmlns:a16="http://schemas.microsoft.com/office/drawing/2014/main" id="{3B15584E-389C-DF07-3327-D8AC0B383C88}"/>
+            </a:ext>
+          </a:extLst>
+        </p:cNvPr>
+        <p:cNvGrpSpPr/>
+        <p:nvPr/>
+      </p:nvGrpSpPr>
+      <p:grpSpPr>
+        <a:xfrm>
+          <a:off x="0" y="0"/>
+          <a:ext cx="0" cy="0"/>
+          <a:chOff x="0" y="0"/>
+          <a:chExt cx="0" cy="0"/>
+        </a:xfrm>
+      </p:grpSpPr>
+      <p:sp>
+        <p:nvSpPr>
+          <p:cNvPr id="2" name="Title 1">
+            <a:extLst>
+              <a:ext uri="{FF2B5EF4-FFF2-40B4-BE49-F238E27FC236}">
+                <a16:creationId xmlns:a16="http://schemas.microsoft.com/office/drawing/2014/main" id="{08FEC0F6-8077-39C4-12BD-E7A01262AF54}"/>
+              </a:ext>
+            </a:extLst>
+          </p:cNvPr>
+          <p:cNvSpPr>
+            <a:spLocks noGrp="1"/>
+          </p:cNvSpPr>
+          <p:nvPr>
+            <p:ph type="title"/>
+          </p:nvPr>
+        </p:nvSpPr>
+        <p:spPr>
+          <a:xfrm>
+            <a:off x="1011608" y="0"/>
+            <a:ext cx="7958331" cy="1077229"/>
+          </a:xfrm>
+        </p:spPr>
+        <p:txBody>
+          <a:bodyPr/>
+          <a:lstStyle/>
+          <a:p>
+            <a:pPr algn="l"/>
+            <a:r>
+              <a:rPr lang="es-CL" dirty="0" err="1"/>
+              <a:t>FrontEnd</a:t>
+            </a:r>
+            <a:endParaRPr lang="es-CL" dirty="0"/>
+          </a:p>
+        </p:txBody>
+      </p:sp>
+      <p:pic>
+        <p:nvPicPr>
+          <p:cNvPr id="9" name="Picture 8" descr="File:React-icon.svg - Wikimedia Commons">
+            <a:extLst>
+              <a:ext uri="{FF2B5EF4-FFF2-40B4-BE49-F238E27FC236}">
+                <a16:creationId xmlns:a16="http://schemas.microsoft.com/office/drawing/2014/main" id="{2791305D-BA90-E9AD-475E-269DD0A87BE1}"/>
+              </a:ext>
+            </a:extLst>
+          </p:cNvPr>
+          <p:cNvPicPr>
+            <a:picLocks noChangeAspect="1"/>
+          </p:cNvPicPr>
+          <p:nvPr/>
+        </p:nvPicPr>
+        <p:blipFill>
+          <a:blip r:embed="rId2"/>
+          <a:stretch>
+            <a:fillRect/>
+          </a:stretch>
+        </p:blipFill>
+        <p:spPr>
+          <a:xfrm>
+            <a:off x="9643437" y="110451"/>
+            <a:ext cx="1563731" cy="1392698"/>
+          </a:xfrm>
+          <a:prstGeom prst="rect">
+            <a:avLst/>
+          </a:prstGeom>
+        </p:spPr>
+      </p:pic>
+      <p:pic>
+        <p:nvPicPr>
+          <p:cNvPr id="4" name="Picture 3">
+            <a:extLst>
+              <a:ext uri="{FF2B5EF4-FFF2-40B4-BE49-F238E27FC236}">
+                <a16:creationId xmlns:a16="http://schemas.microsoft.com/office/drawing/2014/main" id="{5426A9E6-548C-EF11-2210-6B3A09F3D707}"/>
+              </a:ext>
+            </a:extLst>
+          </p:cNvPr>
+          <p:cNvPicPr>
+            <a:picLocks noChangeAspect="1"/>
+          </p:cNvPicPr>
+          <p:nvPr/>
+        </p:nvPicPr>
+        <p:blipFill>
+          <a:blip r:embed="rId3"/>
+          <a:stretch>
+            <a:fillRect/>
+          </a:stretch>
+        </p:blipFill>
+        <p:spPr>
+          <a:xfrm>
+            <a:off x="1018032" y="806800"/>
+            <a:ext cx="5266359" cy="2849066"/>
+          </a:xfrm>
+          <a:prstGeom prst="rect">
+            <a:avLst/>
+          </a:prstGeom>
+        </p:spPr>
+      </p:pic>
+      <p:pic>
+        <p:nvPicPr>
+          <p:cNvPr id="6" name="Picture 5">
+            <a:extLst>
+              <a:ext uri="{FF2B5EF4-FFF2-40B4-BE49-F238E27FC236}">
+                <a16:creationId xmlns:a16="http://schemas.microsoft.com/office/drawing/2014/main" id="{D90F20BA-910E-5645-6E47-887F7C487544}"/>
+              </a:ext>
+            </a:extLst>
+          </p:cNvPr>
+          <p:cNvPicPr>
+            <a:picLocks noChangeAspect="1"/>
+          </p:cNvPicPr>
+          <p:nvPr/>
+        </p:nvPicPr>
+        <p:blipFill>
+          <a:blip r:embed="rId4"/>
+          <a:stretch>
+            <a:fillRect/>
+          </a:stretch>
+        </p:blipFill>
+        <p:spPr>
+          <a:xfrm>
+            <a:off x="1018032" y="3796599"/>
+            <a:ext cx="5266359" cy="2902194"/>
+          </a:xfrm>
+          <a:prstGeom prst="rect">
+            <a:avLst/>
+          </a:prstGeom>
+        </p:spPr>
+      </p:pic>
+    </p:spTree>
+    <p:extLst>
+      <p:ext uri="{BB962C8B-B14F-4D97-AF65-F5344CB8AC3E}">
+        <p14:creationId xmlns:p14="http://schemas.microsoft.com/office/powerpoint/2010/main" val="941936541"/>
+      </p:ext>
+    </p:extLst>
+  </p:cSld>
+  <p:clrMapOvr>
+    <a:masterClrMapping/>
+  </p:clrMapOvr>
+</p:sld>
+</file>
+
+<file path=ppt/slides/slide8.xml><?xml version="1.0" encoding="utf-8"?>
+<p:sld xmlns:a="http://schemas.openxmlformats.org/drawingml/2006/main" xmlns:r="http://schemas.openxmlformats.org/officeDocument/2006/relationships" xmlns:p="http://schemas.openxmlformats.org/presentationml/2006/main">
+  <p:cSld>
+    <p:spTree>
+      <p:nvGrpSpPr>
+        <p:cNvPr id="1" name="">
+          <a:extLst>
+            <a:ext uri="{FF2B5EF4-FFF2-40B4-BE49-F238E27FC236}">
+              <a16:creationId xmlns:a16="http://schemas.microsoft.com/office/drawing/2014/main" id="{A40D897E-D522-9556-E4C4-DF8B53236221}"/>
+            </a:ext>
+          </a:extLst>
+        </p:cNvPr>
+        <p:cNvGrpSpPr/>
+        <p:nvPr/>
+      </p:nvGrpSpPr>
+      <p:grpSpPr>
+        <a:xfrm>
+          <a:off x="0" y="0"/>
+          <a:ext cx="0" cy="0"/>
+          <a:chOff x="0" y="0"/>
+          <a:chExt cx="0" cy="0"/>
+        </a:xfrm>
+      </p:grpSpPr>
+      <p:sp>
+        <p:nvSpPr>
+          <p:cNvPr id="2" name="Title 1">
+            <a:extLst>
+              <a:ext uri="{FF2B5EF4-FFF2-40B4-BE49-F238E27FC236}">
+                <a16:creationId xmlns:a16="http://schemas.microsoft.com/office/drawing/2014/main" id="{D424CE83-FE30-6BAA-9FC3-32A70CF529C3}"/>
+              </a:ext>
+            </a:extLst>
+          </p:cNvPr>
+          <p:cNvSpPr>
+            <a:spLocks noGrp="1"/>
+          </p:cNvSpPr>
+          <p:nvPr>
+            <p:ph type="title"/>
+          </p:nvPr>
+        </p:nvSpPr>
+        <p:spPr>
+          <a:xfrm>
+            <a:off x="1011608" y="0"/>
+            <a:ext cx="7958331" cy="1077229"/>
+          </a:xfrm>
+        </p:spPr>
+        <p:txBody>
+          <a:bodyPr/>
+          <a:lstStyle/>
+          <a:p>
+            <a:pPr algn="l"/>
+            <a:r>
+              <a:rPr lang="es-CL" dirty="0" err="1"/>
+              <a:t>FrontEnd</a:t>
+            </a:r>
+            <a:endParaRPr lang="es-CL" dirty="0"/>
+          </a:p>
+        </p:txBody>
+      </p:sp>
+      <p:pic>
+        <p:nvPicPr>
+          <p:cNvPr id="9" name="Picture 8" descr="File:React-icon.svg - Wikimedia Commons">
+            <a:extLst>
+              <a:ext uri="{FF2B5EF4-FFF2-40B4-BE49-F238E27FC236}">
+                <a16:creationId xmlns:a16="http://schemas.microsoft.com/office/drawing/2014/main" id="{95F51F7F-DB2F-FBA9-64F9-A4DC809D3C00}"/>
+              </a:ext>
+            </a:extLst>
+          </p:cNvPr>
+          <p:cNvPicPr>
+            <a:picLocks noChangeAspect="1"/>
+          </p:cNvPicPr>
+          <p:nvPr/>
+        </p:nvPicPr>
+        <p:blipFill>
+          <a:blip r:embed="rId2"/>
+          <a:stretch>
+            <a:fillRect/>
+          </a:stretch>
+        </p:blipFill>
+        <p:spPr>
+          <a:xfrm>
+            <a:off x="9643437" y="110451"/>
+            <a:ext cx="1563731" cy="1392698"/>
+          </a:xfrm>
+          <a:prstGeom prst="rect">
+            <a:avLst/>
+          </a:prstGeom>
+        </p:spPr>
+      </p:pic>
+      <p:pic>
+        <p:nvPicPr>
+          <p:cNvPr id="4" name="Picture 3">
+            <a:extLst>
+              <a:ext uri="{FF2B5EF4-FFF2-40B4-BE49-F238E27FC236}">
+                <a16:creationId xmlns:a16="http://schemas.microsoft.com/office/drawing/2014/main" id="{B96D0D89-6882-5A23-1BFA-BD668D6FEBC0}"/>
+              </a:ext>
+            </a:extLst>
+          </p:cNvPr>
+          <p:cNvPicPr>
+            <a:picLocks noChangeAspect="1"/>
+          </p:cNvPicPr>
+          <p:nvPr/>
+        </p:nvPicPr>
+        <p:blipFill>
+          <a:blip r:embed="rId3"/>
+          <a:stretch>
+            <a:fillRect/>
+          </a:stretch>
+        </p:blipFill>
+        <p:spPr>
+          <a:xfrm>
+            <a:off x="1011608" y="485502"/>
+            <a:ext cx="5606180" cy="2943498"/>
+          </a:xfrm>
+          <a:prstGeom prst="rect">
+            <a:avLst/>
+          </a:prstGeom>
+        </p:spPr>
+      </p:pic>
+      <p:pic>
+        <p:nvPicPr>
+          <p:cNvPr id="6" name="Picture 5">
+            <a:extLst>
+              <a:ext uri="{FF2B5EF4-FFF2-40B4-BE49-F238E27FC236}">
+                <a16:creationId xmlns:a16="http://schemas.microsoft.com/office/drawing/2014/main" id="{55D2B16F-C81D-84ED-3896-FC06C88E916E}"/>
+              </a:ext>
+            </a:extLst>
+          </p:cNvPr>
+          <p:cNvPicPr>
+            <a:picLocks noChangeAspect="1"/>
+          </p:cNvPicPr>
+          <p:nvPr/>
+        </p:nvPicPr>
+        <p:blipFill>
+          <a:blip r:embed="rId4"/>
+          <a:stretch>
+            <a:fillRect/>
+          </a:stretch>
+        </p:blipFill>
+        <p:spPr>
+          <a:xfrm>
+            <a:off x="1078992" y="3721608"/>
+            <a:ext cx="6022521" cy="1408176"/>
+          </a:xfrm>
+          <a:prstGeom prst="rect">
+            <a:avLst/>
+          </a:prstGeom>
+        </p:spPr>
+      </p:pic>
+      <p:pic>
+        <p:nvPicPr>
+          <p:cNvPr id="8" name="Picture 7">
+            <a:extLst>
+              <a:ext uri="{FF2B5EF4-FFF2-40B4-BE49-F238E27FC236}">
+                <a16:creationId xmlns:a16="http://schemas.microsoft.com/office/drawing/2014/main" id="{19CD86A0-4254-33E1-FFF1-EC0491AE6447}"/>
+              </a:ext>
+            </a:extLst>
+          </p:cNvPr>
+          <p:cNvPicPr>
+            <a:picLocks noChangeAspect="1"/>
+          </p:cNvPicPr>
+          <p:nvPr/>
+        </p:nvPicPr>
+        <p:blipFill>
+          <a:blip r:embed="rId5"/>
+          <a:stretch>
+            <a:fillRect/>
+          </a:stretch>
+        </p:blipFill>
+        <p:spPr>
+          <a:xfrm>
+            <a:off x="8296983" y="3303176"/>
+            <a:ext cx="3370110" cy="2437063"/>
+          </a:xfrm>
+          <a:prstGeom prst="rect">
+            <a:avLst/>
+          </a:prstGeom>
+        </p:spPr>
+      </p:pic>
+      <p:sp>
+        <p:nvSpPr>
+          <p:cNvPr id="11" name="Arrow: Right 10">
+            <a:extLst>
+              <a:ext uri="{FF2B5EF4-FFF2-40B4-BE49-F238E27FC236}">
+                <a16:creationId xmlns:a16="http://schemas.microsoft.com/office/drawing/2014/main" id="{D0E72A4A-22CB-8813-9582-809288C8E768}"/>
+              </a:ext>
+            </a:extLst>
+          </p:cNvPr>
+          <p:cNvSpPr/>
+          <p:nvPr/>
+        </p:nvSpPr>
+        <p:spPr>
+          <a:xfrm>
+            <a:off x="7168896" y="4037076"/>
+            <a:ext cx="1060704" cy="777240"/>
+          </a:xfrm>
+          <a:prstGeom prst="rightArrow">
+            <a:avLst/>
+          </a:prstGeom>
+        </p:spPr>
+        <p:style>
+          <a:lnRef idx="2">
+            <a:schemeClr val="accent1">
+              <a:shade val="15000"/>
+            </a:schemeClr>
+          </a:lnRef>
+          <a:fillRef idx="1">
+            <a:schemeClr val="accent1"/>
+          </a:fillRef>
+          <a:effectRef idx="0">
+            <a:schemeClr val="accent1"/>
+          </a:effectRef>
+          <a:fontRef idx="minor">
+            <a:schemeClr val="lt1"/>
+          </a:fontRef>
+        </p:style>
+        <p:txBody>
+          <a:bodyPr rtlCol="0" anchor="ctr"/>
+          <a:lstStyle/>
+          <a:p>
+            <a:pPr algn="ctr"/>
+            <a:endParaRPr lang="es-CL"/>
+          </a:p>
+        </p:txBody>
+      </p:sp>
+    </p:spTree>
+    <p:extLst>
+      <p:ext uri="{BB962C8B-B14F-4D97-AF65-F5344CB8AC3E}">
+        <p14:creationId xmlns:p14="http://schemas.microsoft.com/office/powerpoint/2010/main" val="1607210510"/>
       </p:ext>
     </p:extLst>
   </p:cSld>
@@ -7555,7 +6725,13 @@
   <p:cSld>
     <p:spTree>
       <p:nvGrpSpPr>
-        <p:cNvPr id="1" name=""/>
+        <p:cNvPr id="1" name="">
+          <a:extLst>
+            <a:ext uri="{FF2B5EF4-FFF2-40B4-BE49-F238E27FC236}">
+              <a16:creationId xmlns:a16="http://schemas.microsoft.com/office/drawing/2014/main" id="{30F3FBBC-CDFB-9E77-7C7E-691B454F39C4}"/>
+            </a:ext>
+          </a:extLst>
+        </p:cNvPr>
         <p:cNvGrpSpPr/>
         <p:nvPr/>
       </p:nvGrpSpPr>
@@ -7572,7 +6748,7 @@
           <p:cNvPr id="2" name="Title 1">
             <a:extLst>
               <a:ext uri="{FF2B5EF4-FFF2-40B4-BE49-F238E27FC236}">
-                <a16:creationId xmlns:a16="http://schemas.microsoft.com/office/drawing/2014/main" id="{F596DFCA-63C8-B662-6429-66D22AAC1C6B}"/>
+                <a16:creationId xmlns:a16="http://schemas.microsoft.com/office/drawing/2014/main" id="{8CACA0F6-5F77-9E91-E44D-7A1792F9C6AB}"/>
               </a:ext>
             </a:extLst>
           </p:cNvPr>
@@ -7585,7 +6761,7 @@
         </p:nvSpPr>
         <p:spPr>
           <a:xfrm>
-            <a:off x="691569" y="76536"/>
+            <a:off x="344097" y="17480"/>
             <a:ext cx="2527120" cy="1077229"/>
           </a:xfrm>
         </p:spPr>
@@ -7594,18 +6770,65 @@
           <a:lstStyle/>
           <a:p>
             <a:r>
-              <a:rPr lang="es-CL" dirty="0"/>
-              <a:t>Evidencias</a:t>
-            </a:r>
+              <a:rPr lang="es-CL" dirty="0" err="1"/>
+              <a:t>Frontend</a:t>
+            </a:r>
+            <a:endParaRPr lang="es-CL" dirty="0"/>
+          </a:p>
+        </p:txBody>
+      </p:sp>
+      <p:sp>
+        <p:nvSpPr>
+          <p:cNvPr id="15" name="Arrow: Right 14">
+            <a:extLst>
+              <a:ext uri="{FF2B5EF4-FFF2-40B4-BE49-F238E27FC236}">
+                <a16:creationId xmlns:a16="http://schemas.microsoft.com/office/drawing/2014/main" id="{AAA5A19F-1633-E8AA-7D3B-797CA6CDD5A9}"/>
+              </a:ext>
+            </a:extLst>
+          </p:cNvPr>
+          <p:cNvSpPr/>
+          <p:nvPr/>
+        </p:nvSpPr>
+        <p:spPr>
+          <a:xfrm rot="5400000">
+            <a:off x="5191507" y="4046092"/>
+            <a:ext cx="532603" cy="427484"/>
+          </a:xfrm>
+          <a:prstGeom prst="rightArrow">
+            <a:avLst/>
+          </a:prstGeom>
+        </p:spPr>
+        <p:style>
+          <a:lnRef idx="2">
+            <a:schemeClr val="accent1">
+              <a:shade val="15000"/>
+            </a:schemeClr>
+          </a:lnRef>
+          <a:fillRef idx="1">
+            <a:schemeClr val="accent1"/>
+          </a:fillRef>
+          <a:effectRef idx="0">
+            <a:schemeClr val="accent1"/>
+          </a:effectRef>
+          <a:fontRef idx="minor">
+            <a:schemeClr val="lt1"/>
+          </a:fontRef>
+        </p:style>
+        <p:txBody>
+          <a:bodyPr rtlCol="0" anchor="ctr"/>
+          <a:lstStyle/>
+          <a:p>
+            <a:pPr algn="ctr"/>
+            <a:endParaRPr lang="es-CL" dirty="0"/>
           </a:p>
         </p:txBody>
       </p:sp>
       <p:pic>
         <p:nvPicPr>
-          <p:cNvPr id="8" name="Picture 7">
+          <p:cNvPr id="7" name="Picture 6">
             <a:extLst>
               <a:ext uri="{FF2B5EF4-FFF2-40B4-BE49-F238E27FC236}">
-                <a16:creationId xmlns:a16="http://schemas.microsoft.com/office/drawing/2014/main" id="{EE5D7928-1C9B-F7A4-69D8-290ECA81F4F7}"/>
+                <a16:creationId xmlns:a16="http://schemas.microsoft.com/office/drawing/2014/main" id="{98282D21-1C88-8FF8-0BF3-998A5D43AC39}"/>
               </a:ext>
             </a:extLst>
           </p:cNvPr>
@@ -7622,55 +6845,20 @@
         </p:blipFill>
         <p:spPr>
           <a:xfrm>
-            <a:off x="950977" y="615150"/>
-            <a:ext cx="5371155" cy="2653213"/>
+            <a:off x="1095593" y="740761"/>
+            <a:ext cx="7174545" cy="3172079"/>
           </a:xfrm>
           <a:prstGeom prst="rect">
             <a:avLst/>
           </a:prstGeom>
         </p:spPr>
       </p:pic>
-      <p:sp>
-        <p:nvSpPr>
-          <p:cNvPr id="9" name="TextBox 8">
+      <p:pic>
+        <p:nvPicPr>
+          <p:cNvPr id="10" name="Picture 9">
             <a:extLst>
               <a:ext uri="{FF2B5EF4-FFF2-40B4-BE49-F238E27FC236}">
-                <a16:creationId xmlns:a16="http://schemas.microsoft.com/office/drawing/2014/main" id="{FBF45608-4722-E277-1126-B907F0A213FA}"/>
-              </a:ext>
-            </a:extLst>
-          </p:cNvPr>
-          <p:cNvSpPr txBox="1"/>
-          <p:nvPr/>
-        </p:nvSpPr>
-        <p:spPr>
-          <a:xfrm>
-            <a:off x="6431860" y="1153765"/>
-            <a:ext cx="4918891" cy="369332"/>
-          </a:xfrm>
-          <a:prstGeom prst="rect">
-            <a:avLst/>
-          </a:prstGeom>
-          <a:noFill/>
-        </p:spPr>
-        <p:txBody>
-          <a:bodyPr wrap="square" rtlCol="0">
-            <a:spAutoFit/>
-          </a:bodyPr>
-          <a:lstStyle/>
-          <a:p>
-            <a:r>
-              <a:rPr lang="es-CL" dirty="0"/>
-              <a:t>Inicio</a:t>
-            </a:r>
-          </a:p>
-        </p:txBody>
-      </p:sp>
-      <p:pic>
-        <p:nvPicPr>
-          <p:cNvPr id="11" name="Picture 10">
-            <a:extLst>
-              <a:ext uri="{FF2B5EF4-FFF2-40B4-BE49-F238E27FC236}">
-                <a16:creationId xmlns:a16="http://schemas.microsoft.com/office/drawing/2014/main" id="{2F5457CF-402F-BE64-6054-276C401F1E61}"/>
+                <a16:creationId xmlns:a16="http://schemas.microsoft.com/office/drawing/2014/main" id="{2AE3AE65-7C1C-3336-FC76-BE65D5D69B84}"/>
               </a:ext>
             </a:extLst>
           </p:cNvPr>
@@ -7687,83 +6875,18 @@
         </p:blipFill>
         <p:spPr>
           <a:xfrm>
-            <a:off x="950977" y="3268362"/>
-            <a:ext cx="5371154" cy="2933525"/>
+            <a:off x="1095593" y="3993532"/>
+            <a:ext cx="4579632" cy="2698049"/>
           </a:xfrm>
           <a:prstGeom prst="rect">
             <a:avLst/>
           </a:prstGeom>
         </p:spPr>
       </p:pic>
-      <p:pic>
-        <p:nvPicPr>
-          <p:cNvPr id="13" name="Picture 12">
-            <a:extLst>
-              <a:ext uri="{FF2B5EF4-FFF2-40B4-BE49-F238E27FC236}">
-                <a16:creationId xmlns:a16="http://schemas.microsoft.com/office/drawing/2014/main" id="{32397C4E-7C4E-DE55-454B-E7C3F0054D43}"/>
-              </a:ext>
-            </a:extLst>
-          </p:cNvPr>
-          <p:cNvPicPr>
-            <a:picLocks noChangeAspect="1"/>
-          </p:cNvPicPr>
-          <p:nvPr/>
-        </p:nvPicPr>
-        <p:blipFill>
-          <a:blip r:embed="rId4"/>
-          <a:stretch>
-            <a:fillRect/>
-          </a:stretch>
-        </p:blipFill>
-        <p:spPr>
-          <a:xfrm>
-            <a:off x="6322131" y="3422903"/>
-            <a:ext cx="2084238" cy="2778983"/>
-          </a:xfrm>
-          <a:prstGeom prst="rect">
-            <a:avLst/>
-          </a:prstGeom>
-        </p:spPr>
-      </p:pic>
-      <p:sp>
-        <p:nvSpPr>
-          <p:cNvPr id="14" name="TextBox 13">
-            <a:extLst>
-              <a:ext uri="{FF2B5EF4-FFF2-40B4-BE49-F238E27FC236}">
-                <a16:creationId xmlns:a16="http://schemas.microsoft.com/office/drawing/2014/main" id="{FA88E470-012C-8D78-09A6-846638B2958A}"/>
-              </a:ext>
-            </a:extLst>
-          </p:cNvPr>
-          <p:cNvSpPr txBox="1"/>
-          <p:nvPr/>
-        </p:nvSpPr>
-        <p:spPr>
-          <a:xfrm>
-            <a:off x="8406369" y="3422903"/>
-            <a:ext cx="3364992" cy="369332"/>
-          </a:xfrm>
-          <a:prstGeom prst="rect">
-            <a:avLst/>
-          </a:prstGeom>
-          <a:noFill/>
-        </p:spPr>
-        <p:txBody>
-          <a:bodyPr wrap="square" rtlCol="0">
-            <a:spAutoFit/>
-          </a:bodyPr>
-          <a:lstStyle/>
-          <a:p>
-            <a:r>
-              <a:rPr lang="es-CL" dirty="0"/>
-              <a:t>Login y registro</a:t>
-            </a:r>
-          </a:p>
-        </p:txBody>
-      </p:sp>
     </p:spTree>
     <p:extLst>
       <p:ext uri="{BB962C8B-B14F-4D97-AF65-F5344CB8AC3E}">
-        <p14:creationId xmlns:p14="http://schemas.microsoft.com/office/powerpoint/2010/main" val="3682387179"/>
+        <p14:creationId xmlns:p14="http://schemas.microsoft.com/office/powerpoint/2010/main" val="1398064454"/>
       </p:ext>
     </p:extLst>
   </p:cSld>

</xml_diff>